<commit_message>
docs: add comprehensive tech stack and engineering solutions guide [2.25.0]
</commit_message>
<xml_diff>
--- a/docs/PharmaConnect_Defense_Presentation.pptx
+++ b/docs/PharmaConnect_Defense_Presentation.pptx
@@ -3216,7 +3216,7 @@
               </a:defRPr>
             </a:pPr>
             <a:r>
-              <a:t>مشروع مناقشة مقرر بنية وبرمجة أنظمة الخادم والعميل (Level 4)</a:t>
+              <a:t>منظومة خادم وعميل متقدمة (3-Tier Distributed Architecture)</a:t>
             </a:r>
           </a:p>
           <a:p>
@@ -3295,7 +3295,7 @@
               </a:defRPr>
             </a:pPr>
             <a:r>
-              <a:t>إشراف ومناقشة: لجنة التحكيم الأكاديمية الموقرة  |  سبتمبر 2026</a:t>
+              <a:t>عرض النظام والحلول المعمارية والتطبيقية  |  2026</a:t>
             </a:r>
           </a:p>
         </p:txBody>
@@ -3430,7 +3430,7 @@
               </a:defRPr>
             </a:pPr>
             <a:r>
-              <a:t>9. الخاتمة وبطاقة إجابات البرق أمام اللجنة (Defense QA)</a:t>
+              <a:t>9. الخاتمة والمعايير الهندسية المعتمدة (Technical Standards &amp; FAQ)</a:t>
             </a:r>
           </a:p>
         </p:txBody>
@@ -3767,7 +3767,7 @@
               </a:defRPr>
             </a:pPr>
             <a:r>
-              <a:t>بطاقة إجابات البرق الحاسمة (Pocket QA)</a:t>
+              <a:t>أهم المعايير والأسئلة التقنية الشائعة (Technical FAQ)</a:t>
             </a:r>
           </a:p>
           <a:p>
@@ -3783,7 +3783,7 @@
               </a:defRPr>
             </a:pPr>
             <a:r>
-              <a:t>• س: أين منعتم الـ Race Condition؟ -&gt; دالة createReservation بـ lockForUpdate داخل DB::transaction.</a:t>
+              <a:t>• س: أين معالجة الـ Race Condition؟ -&gt; دالة createReservation بـ lockForUpdate داخل DB::transaction.</a:t>
             </a:r>
           </a:p>
           <a:p>
@@ -3815,7 +3815,7 @@
               </a:defRPr>
             </a:pPr>
             <a:r>
-              <a:t>• س: كيف تحافظون على الأمان بدون Session بالموبايل؟ -&gt; توكنات مشفرة Bearer Token عبر Laravel Sanctum.</a:t>
+              <a:t>• س: كيف يعمل الأمان بدون Session بالموبايل؟ -&gt; توكنات مشفرة Bearer Token عبر Laravel Sanctum.</a:t>
             </a:r>
           </a:p>
           <a:p>
@@ -5472,7 +5472,7 @@
               </a:defRPr>
             </a:pPr>
             <a:r>
-              <a:t>مزايا التصميم المعياري أمام اللجنة</a:t>
+              <a:t>المزايا المعمارية والهندسية للتصميم</a:t>
             </a:r>
           </a:p>
           <a:p>
@@ -7751,7 +7751,7 @@
               </a:defRPr>
             </a:pPr>
             <a:r>
-              <a:t>8. سيناريو العرض العملي الحي أمام اللجنة (Live Demo Sequence)</a:t>
+              <a:t>8. سيناريو العرض التشغيلي المباشر (End-to-End System Demo)</a:t>
             </a:r>
           </a:p>
         </p:txBody>
@@ -7911,7 +7911,7 @@
               </a:defRPr>
             </a:pPr>
             <a:r>
-              <a:t>خطة الدقيقتين للعرض المشترك (متصفح الويب + هاتف العميل)</a:t>
+              <a:t>خطوات العرض التشغيلي المتزامن (بوابة الويب + تطبيق الهاتف)</a:t>
             </a:r>
           </a:p>
           <a:p>

</xml_diff>

<commit_message>
docs: add comprehensive explanatory comments to all presentation code snippets [2.27.0]
</commit_message>
<xml_diff>
--- a/docs/PharmaConnect_Defense_Presentation.pptx
+++ b/docs/PharmaConnect_Defense_Presentation.pptx
@@ -8159,7 +8159,7 @@
               </a:defRPr>
             </a:pPr>
             <a:r>
-              <a:t>4. كود التخاطب والمصادقة بالتوكنات (Client-Server Auth &amp; Bearer Tokens)</a:t>
+              <a:t>4. كود التخاطب والمصادقة بالتوكنات (REST Auth &amp; Bearer Tokens)</a:t>
             </a:r>
           </a:p>
         </p:txBody>
@@ -8332,8 +8332,8 @@
         </p:nvSpPr>
         <p:spPr>
           <a:xfrm>
-            <a:off x="914400" y="1801368"/>
-            <a:ext cx="4846320" cy="4251959"/>
+            <a:off x="914400" y="1783080"/>
+            <a:ext cx="4846320" cy="4279392"/>
           </a:xfrm>
           <a:prstGeom prst="rect">
             <a:avLst/>
@@ -8347,7 +8347,7 @@
           <a:lstStyle/>
           <a:p>
             <a:pPr algn="l">
-              <a:defRPr sz="1000">
+              <a:defRPr sz="919">
                 <a:solidFill>
                   <a:srgbClr val="94A3B8"/>
                 </a:solidFill>
@@ -8360,7 +8360,20 @@
           </a:p>
           <a:p>
             <a:pPr algn="l">
-              <a:defRPr sz="1000">
+              <a:defRPr sz="919">
+                <a:solidFill>
+                  <a:srgbClr val="94A3B8"/>
+                </a:solidFill>
+                <a:latin typeface="Consolas"/>
+              </a:defRPr>
+            </a:pPr>
+            <a:r>
+              <a:t>// 1. تجهيز ترويسات الطلب بنمط RESTful وحقن التوكن المشفر</a:t>
+            </a:r>
+          </a:p>
+          <a:p>
+            <a:pPr algn="l">
+              <a:defRPr sz="919">
                 <a:solidFill>
                   <a:srgbClr val="38BDF8"/>
                 </a:solidFill>
@@ -8373,7 +8386,7 @@
           </a:p>
           <a:p>
             <a:pPr algn="l">
-              <a:defRPr sz="1000">
+              <a:defRPr sz="919">
                 <a:solidFill>
                   <a:srgbClr val="38BDF8"/>
                 </a:solidFill>
@@ -8386,7 +8399,7 @@
           </a:p>
           <a:p>
             <a:pPr algn="l">
-              <a:defRPr sz="1000">
+              <a:defRPr sz="919">
                 <a:solidFill>
                   <a:srgbClr val="38BDF8"/>
                 </a:solidFill>
@@ -8399,7 +8412,7 @@
           </a:p>
           <a:p>
             <a:pPr algn="l">
-              <a:defRPr sz="1000">
+              <a:defRPr sz="919">
                 <a:solidFill>
                   <a:srgbClr val="F472B6"/>
                 </a:solidFill>
@@ -8412,20 +8425,20 @@
           </a:p>
           <a:p>
             <a:pPr algn="l">
-              <a:defRPr sz="1000">
-                <a:solidFill>
-                  <a:srgbClr val="38BDF8"/>
-                </a:solidFill>
-                <a:latin typeface="Consolas"/>
-              </a:defRPr>
-            </a:pPr>
-            <a:r>
-              <a:t>    'Authorization': 'Bearer $_authToken',</a:t>
-            </a:r>
-          </a:p>
-          <a:p>
-            <a:pPr algn="l">
-              <a:defRPr sz="1000">
+              <a:defRPr sz="919">
+                <a:solidFill>
+                  <a:srgbClr val="38BDF8"/>
+                </a:solidFill>
+                <a:latin typeface="Consolas"/>
+              </a:defRPr>
+            </a:pPr>
+            <a:r>
+              <a:t>    'Authorization': 'Bearer $_authToken', // توكن مصادقة العميل</a:t>
+            </a:r>
+          </a:p>
+          <a:p>
+            <a:pPr algn="l">
+              <a:defRPr sz="919">
                 <a:solidFill>
                   <a:srgbClr val="38BDF8"/>
                 </a:solidFill>
@@ -8438,17 +8451,30 @@
           </a:p>
           <a:p>
             <a:pPr algn="l">
-              <a:defRPr sz="1000">
-                <a:solidFill>
-                  <a:srgbClr val="38BDF8"/>
-                </a:solidFill>
-                <a:latin typeface="Consolas"/>
-              </a:defRPr>
-            </a:pPr>
-          </a:p>
-          <a:p>
-            <a:pPr algn="l">
-              <a:defRPr sz="1000">
+              <a:defRPr sz="919">
+                <a:solidFill>
+                  <a:srgbClr val="38BDF8"/>
+                </a:solidFill>
+                <a:latin typeface="Consolas"/>
+              </a:defRPr>
+            </a:pPr>
+          </a:p>
+          <a:p>
+            <a:pPr algn="l">
+              <a:defRPr sz="919">
+                <a:solidFill>
+                  <a:srgbClr val="94A3B8"/>
+                </a:solidFill>
+                <a:latin typeface="Consolas"/>
+              </a:defRPr>
+            </a:pPr>
+            <a:r>
+              <a:t>// 2. دالة تسجيل الدخول وإرسال بيانات الاعتماد للخادم المركزي</a:t>
+            </a:r>
+          </a:p>
+          <a:p>
+            <a:pPr algn="l">
+              <a:defRPr sz="919">
                 <a:solidFill>
                   <a:srgbClr val="F472B6"/>
                 </a:solidFill>
@@ -8461,7 +8487,7 @@
           </a:p>
           <a:p>
             <a:pPr algn="l">
-              <a:defRPr sz="1000">
+              <a:defRPr sz="919">
                 <a:solidFill>
                   <a:srgbClr val="38BDF8"/>
                 </a:solidFill>
@@ -8474,7 +8500,7 @@
           </a:p>
           <a:p>
             <a:pPr algn="l">
-              <a:defRPr sz="1000">
+              <a:defRPr sz="919">
                 <a:solidFill>
                   <a:srgbClr val="F472B6"/>
                 </a:solidFill>
@@ -8487,7 +8513,7 @@
           </a:p>
           <a:p>
             <a:pPr algn="l">
-              <a:defRPr sz="1000">
+              <a:defRPr sz="919">
                 <a:solidFill>
                   <a:srgbClr val="38BDF8"/>
                 </a:solidFill>
@@ -8500,7 +8526,7 @@
           </a:p>
           <a:p>
             <a:pPr algn="l">
-              <a:defRPr sz="1000">
+              <a:defRPr sz="919">
                 <a:solidFill>
                   <a:srgbClr val="38BDF8"/>
                 </a:solidFill>
@@ -8513,43 +8539,43 @@
           </a:p>
           <a:p>
             <a:pPr algn="l">
-              <a:defRPr sz="1000">
-                <a:solidFill>
-                  <a:srgbClr val="38BDF8"/>
-                </a:solidFill>
-                <a:latin typeface="Consolas"/>
-              </a:defRPr>
-            </a:pPr>
-            <a:r>
-              <a:t>    body: json.encode({'email': email, 'password': pwd}),</a:t>
-            </a:r>
-          </a:p>
-          <a:p>
-            <a:pPr algn="l">
-              <a:defRPr sz="1000">
-                <a:solidFill>
-                  <a:srgbClr val="38BDF8"/>
-                </a:solidFill>
-                <a:latin typeface="Consolas"/>
-              </a:defRPr>
-            </a:pPr>
-            <a:r>
-              <a:t>  ).timeout(Duration(seconds: 5));</a:t>
-            </a:r>
-          </a:p>
-          <a:p>
-            <a:pPr algn="l">
-              <a:defRPr sz="1000">
-                <a:solidFill>
-                  <a:srgbClr val="38BDF8"/>
-                </a:solidFill>
-                <a:latin typeface="Consolas"/>
-              </a:defRPr>
-            </a:pPr>
-          </a:p>
-          <a:p>
-            <a:pPr algn="l">
-              <a:defRPr sz="1000">
+              <a:defRPr sz="919">
+                <a:solidFill>
+                  <a:srgbClr val="38BDF8"/>
+                </a:solidFill>
+                <a:latin typeface="Consolas"/>
+              </a:defRPr>
+            </a:pPr>
+            <a:r>
+              <a:t>    body: json.encode({'email': email, 'password': pwd}), // تشفير JSON</a:t>
+            </a:r>
+          </a:p>
+          <a:p>
+            <a:pPr algn="l">
+              <a:defRPr sz="919">
+                <a:solidFill>
+                  <a:srgbClr val="38BDF8"/>
+                </a:solidFill>
+                <a:latin typeface="Consolas"/>
+              </a:defRPr>
+            </a:pPr>
+            <a:r>
+              <a:t>  ).timeout(Duration(seconds: 5)); // مهلة حماية من بطء الشبكة</a:t>
+            </a:r>
+          </a:p>
+          <a:p>
+            <a:pPr algn="l">
+              <a:defRPr sz="919">
+                <a:solidFill>
+                  <a:srgbClr val="38BDF8"/>
+                </a:solidFill>
+                <a:latin typeface="Consolas"/>
+              </a:defRPr>
+            </a:pPr>
+          </a:p>
+          <a:p>
+            <a:pPr algn="l">
+              <a:defRPr sz="919">
                 <a:solidFill>
                   <a:srgbClr val="F472B6"/>
                 </a:solidFill>
@@ -8562,7 +8588,7 @@
           </a:p>
           <a:p>
             <a:pPr algn="l">
-              <a:defRPr sz="1000">
+              <a:defRPr sz="919">
                 <a:solidFill>
                   <a:srgbClr val="38BDF8"/>
                 </a:solidFill>
@@ -8575,20 +8601,20 @@
           </a:p>
           <a:p>
             <a:pPr algn="l">
-              <a:defRPr sz="1000">
-                <a:solidFill>
-                  <a:srgbClr val="38BDF8"/>
-                </a:solidFill>
-                <a:latin typeface="Consolas"/>
-              </a:defRPr>
-            </a:pPr>
-            <a:r>
-              <a:t>    _authToken = body['data']['token'];</a:t>
-            </a:r>
-          </a:p>
-          <a:p>
-            <a:pPr algn="l">
-              <a:defRPr sz="1000">
+              <a:defRPr sz="919">
+                <a:solidFill>
+                  <a:srgbClr val="38BDF8"/>
+                </a:solidFill>
+                <a:latin typeface="Consolas"/>
+              </a:defRPr>
+            </a:pPr>
+            <a:r>
+              <a:t>    _authToken = body['data']['token']; // حفظ التوكن محلياً</a:t>
+            </a:r>
+          </a:p>
+          <a:p>
+            <a:pPr algn="l">
+              <a:defRPr sz="919">
                 <a:solidFill>
                   <a:srgbClr val="38BDF8"/>
                 </a:solidFill>
@@ -8601,20 +8627,20 @@
           </a:p>
           <a:p>
             <a:pPr algn="l">
-              <a:defRPr sz="1000">
-                <a:solidFill>
-                  <a:srgbClr val="38BDF8"/>
-                </a:solidFill>
-                <a:latin typeface="Consolas"/>
-              </a:defRPr>
-            </a:pPr>
-            <a:r>
-              <a:t>    notifyListeners();</a:t>
-            </a:r>
-          </a:p>
-          <a:p>
-            <a:pPr algn="l">
-              <a:defRPr sz="1000">
+              <a:defRPr sz="919">
+                <a:solidFill>
+                  <a:srgbClr val="38BDF8"/>
+                </a:solidFill>
+                <a:latin typeface="Consolas"/>
+              </a:defRPr>
+            </a:pPr>
+            <a:r>
+              <a:t>    notifyListeners(); // تحديث واجهات التطبيق فورياً</a:t>
+            </a:r>
+          </a:p>
+          <a:p>
+            <a:pPr algn="l">
+              <a:defRPr sz="919">
                 <a:solidFill>
                   <a:srgbClr val="F472B6"/>
                 </a:solidFill>
@@ -8627,7 +8653,7 @@
           </a:p>
           <a:p>
             <a:pPr algn="l">
-              <a:defRPr sz="1000">
+              <a:defRPr sz="919">
                 <a:solidFill>
                   <a:srgbClr val="38BDF8"/>
                 </a:solidFill>
@@ -8640,7 +8666,7 @@
           </a:p>
           <a:p>
             <a:pPr algn="l">
-              <a:defRPr sz="1000">
+              <a:defRPr sz="919">
                 <a:solidFill>
                   <a:srgbClr val="38BDF8"/>
                 </a:solidFill>
@@ -8742,8 +8768,8 @@
         </p:nvSpPr>
         <p:spPr>
           <a:xfrm>
-            <a:off x="6400800" y="1801368"/>
-            <a:ext cx="4846320" cy="4251959"/>
+            <a:off x="6400800" y="1783080"/>
+            <a:ext cx="4846320" cy="4279392"/>
           </a:xfrm>
           <a:prstGeom prst="rect">
             <a:avLst/>
@@ -8757,7 +8783,7 @@
           <a:lstStyle/>
           <a:p>
             <a:pPr algn="l">
-              <a:defRPr sz="1000">
+              <a:defRPr sz="919">
                 <a:solidFill>
                   <a:srgbClr val="94A3B8"/>
                 </a:solidFill>
@@ -8770,7 +8796,20 @@
           </a:p>
           <a:p>
             <a:pPr algn="l">
-              <a:defRPr sz="1000">
+              <a:defRPr sz="919">
+                <a:solidFill>
+                  <a:srgbClr val="94A3B8"/>
+                </a:solidFill>
+                <a:latin typeface="Consolas"/>
+              </a:defRPr>
+            </a:pPr>
+            <a:r>
+              <a:t>// 1. مسارات الـ API المحمية بواسطة وسيط Laravel Sanctum</a:t>
+            </a:r>
+          </a:p>
+          <a:p>
+            <a:pPr algn="l">
+              <a:defRPr sz="919">
                 <a:solidFill>
                   <a:srgbClr val="F472B6"/>
                 </a:solidFill>
@@ -8783,20 +8822,20 @@
           </a:p>
           <a:p>
             <a:pPr algn="l">
-              <a:defRPr sz="1000">
-                <a:solidFill>
-                  <a:srgbClr val="38BDF8"/>
-                </a:solidFill>
-                <a:latin typeface="Consolas"/>
-              </a:defRPr>
-            </a:pPr>
-            <a:r>
-              <a:t>    Route::post('/auth/login', [AuthController::class, 'login']);</a:t>
-            </a:r>
-          </a:p>
-          <a:p>
-            <a:pPr algn="l">
-              <a:defRPr sz="1000">
+              <a:defRPr sz="919">
+                <a:solidFill>
+                  <a:srgbClr val="38BDF8"/>
+                </a:solidFill>
+                <a:latin typeface="Consolas"/>
+              </a:defRPr>
+            </a:pPr>
+            <a:r>
+              <a:t>    Route::post('/auth/login', [AuthController::class, 'login']); // دخول عام</a:t>
+            </a:r>
+          </a:p>
+          <a:p>
+            <a:pPr algn="l">
+              <a:defRPr sz="919">
                 <a:solidFill>
                   <a:srgbClr val="F472B6"/>
                 </a:solidFill>
@@ -8804,12 +8843,12 @@
               </a:defRPr>
             </a:pPr>
             <a:r>
-              <a:t>    Route::middleware('auth:sanctum')-&gt;group(function () {</a:t>
-            </a:r>
-          </a:p>
-          <a:p>
-            <a:pPr algn="l">
-              <a:defRPr sz="1000">
+              <a:t>    Route::middleware('auth:sanctum')-&gt;group(function () { // مسارات مؤمنة</a:t>
+            </a:r>
+          </a:p>
+          <a:p>
+            <a:pPr algn="l">
+              <a:defRPr sz="919">
                 <a:solidFill>
                   <a:srgbClr val="38BDF8"/>
                 </a:solidFill>
@@ -8822,7 +8861,7 @@
           </a:p>
           <a:p>
             <a:pPr algn="l">
-              <a:defRPr sz="1000">
+              <a:defRPr sz="919">
                 <a:solidFill>
                   <a:srgbClr val="38BDF8"/>
                 </a:solidFill>
@@ -8835,7 +8874,7 @@
           </a:p>
           <a:p>
             <a:pPr algn="l">
-              <a:defRPr sz="1000">
+              <a:defRPr sz="919">
                 <a:solidFill>
                   <a:srgbClr val="38BDF8"/>
                 </a:solidFill>
@@ -8848,7 +8887,7 @@
           </a:p>
           <a:p>
             <a:pPr algn="l">
-              <a:defRPr sz="1000">
+              <a:defRPr sz="919">
                 <a:solidFill>
                   <a:srgbClr val="38BDF8"/>
                 </a:solidFill>
@@ -8861,17 +8900,17 @@
           </a:p>
           <a:p>
             <a:pPr algn="l">
-              <a:defRPr sz="1000">
-                <a:solidFill>
-                  <a:srgbClr val="38BDF8"/>
-                </a:solidFill>
-                <a:latin typeface="Consolas"/>
-              </a:defRPr>
-            </a:pPr>
-          </a:p>
-          <a:p>
-            <a:pPr algn="l">
-              <a:defRPr sz="1000">
+              <a:defRPr sz="919">
+                <a:solidFill>
+                  <a:srgbClr val="38BDF8"/>
+                </a:solidFill>
+                <a:latin typeface="Consolas"/>
+              </a:defRPr>
+            </a:pPr>
+          </a:p>
+          <a:p>
+            <a:pPr algn="l">
+              <a:defRPr sz="919">
                 <a:solidFill>
                   <a:srgbClr val="94A3B8"/>
                 </a:solidFill>
@@ -8884,7 +8923,20 @@
           </a:p>
           <a:p>
             <a:pPr algn="l">
-              <a:defRPr sz="1000">
+              <a:defRPr sz="919">
+                <a:solidFill>
+                  <a:srgbClr val="94A3B8"/>
+                </a:solidFill>
+                <a:latin typeface="Consolas"/>
+              </a:defRPr>
+            </a:pPr>
+            <a:r>
+              <a:t>// 2. التحقق من صحة المدخلات وإصدار توكن Bearer عديم الحالة</a:t>
+            </a:r>
+          </a:p>
+          <a:p>
+            <a:pPr algn="l">
+              <a:defRPr sz="919">
                 <a:solidFill>
                   <a:srgbClr val="F472B6"/>
                 </a:solidFill>
@@ -8897,7 +8949,7 @@
           </a:p>
           <a:p>
             <a:pPr algn="l">
-              <a:defRPr sz="1000">
+              <a:defRPr sz="919">
                 <a:solidFill>
                   <a:srgbClr val="38BDF8"/>
                 </a:solidFill>
@@ -8910,33 +8962,20 @@
           </a:p>
           <a:p>
             <a:pPr algn="l">
-              <a:defRPr sz="1000">
-                <a:solidFill>
-                  <a:srgbClr val="38BDF8"/>
-                </a:solidFill>
-                <a:latin typeface="Consolas"/>
-              </a:defRPr>
-            </a:pPr>
-            <a:r>
-              <a:t>        'email' =&gt; 'required|email',</a:t>
-            </a:r>
-          </a:p>
-          <a:p>
-            <a:pPr algn="l">
-              <a:defRPr sz="1000">
-                <a:solidFill>
-                  <a:srgbClr val="38BDF8"/>
-                </a:solidFill>
-                <a:latin typeface="Consolas"/>
-              </a:defRPr>
-            </a:pPr>
-            <a:r>
-              <a:t>        'password' =&gt; 'required|string'</a:t>
-            </a:r>
-          </a:p>
-          <a:p>
-            <a:pPr algn="l">
-              <a:defRPr sz="1000">
+              <a:defRPr sz="919">
+                <a:solidFill>
+                  <a:srgbClr val="38BDF8"/>
+                </a:solidFill>
+                <a:latin typeface="Consolas"/>
+              </a:defRPr>
+            </a:pPr>
+            <a:r>
+              <a:t>        'email' =&gt; 'required|email', 'password' =&gt; 'required|string'</a:t>
+            </a:r>
+          </a:p>
+          <a:p>
+            <a:pPr algn="l">
+              <a:defRPr sz="919">
                 <a:solidFill>
                   <a:srgbClr val="38BDF8"/>
                 </a:solidFill>
@@ -8949,7 +8988,7 @@
           </a:p>
           <a:p>
             <a:pPr algn="l">
-              <a:defRPr sz="1000">
+              <a:defRPr sz="919">
                 <a:solidFill>
                   <a:srgbClr val="38BDF8"/>
                 </a:solidFill>
@@ -8962,7 +9001,7 @@
           </a:p>
           <a:p>
             <a:pPr algn="l">
-              <a:defRPr sz="1000">
+              <a:defRPr sz="919">
                 <a:solidFill>
                   <a:srgbClr val="F472B6"/>
                 </a:solidFill>
@@ -8975,7 +9014,7 @@
           </a:p>
           <a:p>
             <a:pPr algn="l">
-              <a:defRPr sz="1000">
+              <a:defRPr sz="919">
                 <a:solidFill>
                   <a:srgbClr val="F472B6"/>
                 </a:solidFill>
@@ -8988,7 +9027,7 @@
           </a:p>
           <a:p>
             <a:pPr algn="l">
-              <a:defRPr sz="1000">
+              <a:defRPr sz="919">
                 <a:solidFill>
                   <a:srgbClr val="38BDF8"/>
                 </a:solidFill>
@@ -9001,7 +9040,20 @@
           </a:p>
           <a:p>
             <a:pPr algn="l">
-              <a:defRPr sz="1000">
+              <a:defRPr sz="919">
+                <a:solidFill>
+                  <a:srgbClr val="94A3B8"/>
+                </a:solidFill>
+                <a:latin typeface="Consolas"/>
+              </a:defRPr>
+            </a:pPr>
+            <a:r>
+              <a:t>    // إصدار توكن مشفر خاص بجلسة تطبيق الهاتف</a:t>
+            </a:r>
+          </a:p>
+          <a:p>
+            <a:pPr algn="l">
+              <a:defRPr sz="919">
                 <a:solidFill>
                   <a:srgbClr val="38BDF8"/>
                 </a:solidFill>
@@ -9014,7 +9066,7 @@
           </a:p>
           <a:p>
             <a:pPr algn="l">
-              <a:defRPr sz="1000">
+              <a:defRPr sz="919">
                 <a:solidFill>
                   <a:srgbClr val="F472B6"/>
                 </a:solidFill>
@@ -9027,7 +9079,7 @@
           </a:p>
           <a:p>
             <a:pPr algn="l">
-              <a:defRPr sz="1000">
+              <a:defRPr sz="919">
                 <a:solidFill>
                   <a:srgbClr val="38BDF8"/>
                 </a:solidFill>
@@ -9343,8 +9395,8 @@
         </p:nvSpPr>
         <p:spPr>
           <a:xfrm>
-            <a:off x="914400" y="1801368"/>
-            <a:ext cx="4846320" cy="4251959"/>
+            <a:off x="914400" y="1783080"/>
+            <a:ext cx="4846320" cy="4279392"/>
           </a:xfrm>
           <a:prstGeom prst="rect">
             <a:avLst/>
@@ -9358,7 +9410,7 @@
           <a:lstStyle/>
           <a:p>
             <a:pPr algn="l">
-              <a:defRPr sz="1000">
+              <a:defRPr sz="919">
                 <a:solidFill>
                   <a:srgbClr val="94A3B8"/>
                 </a:solidFill>
@@ -9371,7 +9423,20 @@
           </a:p>
           <a:p>
             <a:pPr algn="l">
-              <a:defRPr sz="1000">
+              <a:defRPr sz="919">
+                <a:solidFill>
+                  <a:srgbClr val="94A3B8"/>
+                </a:solidFill>
+                <a:latin typeface="Consolas"/>
+              </a:defRPr>
+            </a:pPr>
+            <a:r>
+              <a:t>// إرسال طلب حجز دواء مع تحديد مهلة الصلاحية الزمنية</a:t>
+            </a:r>
+          </a:p>
+          <a:p>
+            <a:pPr algn="l">
+              <a:defRPr sz="919">
                 <a:solidFill>
                   <a:srgbClr val="38BDF8"/>
                 </a:solidFill>
@@ -9384,7 +9449,7 @@
           </a:p>
           <a:p>
             <a:pPr algn="l">
-              <a:defRPr sz="1000">
+              <a:defRPr sz="919">
                 <a:solidFill>
                   <a:srgbClr val="38BDF8"/>
                 </a:solidFill>
@@ -9397,7 +9462,7 @@
           </a:p>
           <a:p>
             <a:pPr algn="l">
-              <a:defRPr sz="1000">
+              <a:defRPr sz="919">
                 <a:solidFill>
                   <a:srgbClr val="38BDF8"/>
                 </a:solidFill>
@@ -9410,20 +9475,20 @@
           </a:p>
           <a:p>
             <a:pPr algn="l">
-              <a:defRPr sz="1000">
-                <a:solidFill>
-                  <a:srgbClr val="38BDF8"/>
-                </a:solidFill>
-                <a:latin typeface="Consolas"/>
-              </a:defRPr>
-            </a:pPr>
-            <a:r>
-              <a:t>  int ttlMinutes = 30,</a:t>
-            </a:r>
-          </a:p>
-          <a:p>
-            <a:pPr algn="l">
-              <a:defRPr sz="1000">
+              <a:defRPr sz="919">
+                <a:solidFill>
+                  <a:srgbClr val="38BDF8"/>
+                </a:solidFill>
+                <a:latin typeface="Consolas"/>
+              </a:defRPr>
+            </a:pPr>
+            <a:r>
+              <a:t>  int ttlMinutes = 30, // مهلة الحجز الافتراضية 30 دقيقة</a:t>
+            </a:r>
+          </a:p>
+          <a:p>
+            <a:pPr algn="l">
+              <a:defRPr sz="919">
                 <a:solidFill>
                   <a:srgbClr val="F472B6"/>
                 </a:solidFill>
@@ -9436,7 +9501,7 @@
           </a:p>
           <a:p>
             <a:pPr algn="l">
-              <a:defRPr sz="1000">
+              <a:defRPr sz="919">
                 <a:solidFill>
                   <a:srgbClr val="38BDF8"/>
                 </a:solidFill>
@@ -9449,7 +9514,7 @@
           </a:p>
           <a:p>
             <a:pPr algn="l">
-              <a:defRPr sz="1000">
+              <a:defRPr sz="919">
                 <a:solidFill>
                   <a:srgbClr val="F472B6"/>
                 </a:solidFill>
@@ -9462,7 +9527,7 @@
           </a:p>
           <a:p>
             <a:pPr algn="l">
-              <a:defRPr sz="1000">
+              <a:defRPr sz="919">
                 <a:solidFill>
                   <a:srgbClr val="38BDF8"/>
                 </a:solidFill>
@@ -9475,7 +9540,7 @@
           </a:p>
           <a:p>
             <a:pPr algn="l">
-              <a:defRPr sz="1000">
+              <a:defRPr sz="919">
                 <a:solidFill>
                   <a:srgbClr val="38BDF8"/>
                 </a:solidFill>
@@ -9488,7 +9553,7 @@
           </a:p>
           <a:p>
             <a:pPr algn="l">
-              <a:defRPr sz="1000">
+              <a:defRPr sz="919">
                 <a:solidFill>
                   <a:srgbClr val="38BDF8"/>
                 </a:solidFill>
@@ -9501,46 +9566,46 @@
           </a:p>
           <a:p>
             <a:pPr algn="l">
-              <a:defRPr sz="1000">
-                <a:solidFill>
-                  <a:srgbClr val="38BDF8"/>
-                </a:solidFill>
-                <a:latin typeface="Consolas"/>
-              </a:defRPr>
-            </a:pPr>
-            <a:r>
-              <a:t>      'pharmacy_medicine_id': stockId,</a:t>
-            </a:r>
-          </a:p>
-          <a:p>
-            <a:pPr algn="l">
-              <a:defRPr sz="1000">
-                <a:solidFill>
-                  <a:srgbClr val="38BDF8"/>
-                </a:solidFill>
-                <a:latin typeface="Consolas"/>
-              </a:defRPr>
-            </a:pPr>
-            <a:r>
-              <a:t>      'quantity': quantity,</a:t>
-            </a:r>
-          </a:p>
-          <a:p>
-            <a:pPr algn="l">
-              <a:defRPr sz="1000">
-                <a:solidFill>
-                  <a:srgbClr val="38BDF8"/>
-                </a:solidFill>
-                <a:latin typeface="Consolas"/>
-              </a:defRPr>
-            </a:pPr>
-            <a:r>
-              <a:t>      'ttl_minutes': ttlMinutes,</a:t>
-            </a:r>
-          </a:p>
-          <a:p>
-            <a:pPr algn="l">
-              <a:defRPr sz="1000">
+              <a:defRPr sz="919">
+                <a:solidFill>
+                  <a:srgbClr val="38BDF8"/>
+                </a:solidFill>
+                <a:latin typeface="Consolas"/>
+              </a:defRPr>
+            </a:pPr>
+            <a:r>
+              <a:t>      'pharmacy_medicine_id': stockId, // معرف الدواء بالصيدلية</a:t>
+            </a:r>
+          </a:p>
+          <a:p>
+            <a:pPr algn="l">
+              <a:defRPr sz="919">
+                <a:solidFill>
+                  <a:srgbClr val="38BDF8"/>
+                </a:solidFill>
+                <a:latin typeface="Consolas"/>
+              </a:defRPr>
+            </a:pPr>
+            <a:r>
+              <a:t>      'quantity': quantity,             // الكمية المطلوبة</a:t>
+            </a:r>
+          </a:p>
+          <a:p>
+            <a:pPr algn="l">
+              <a:defRPr sz="919">
+                <a:solidFill>
+                  <a:srgbClr val="38BDF8"/>
+                </a:solidFill>
+                <a:latin typeface="Consolas"/>
+              </a:defRPr>
+            </a:pPr>
+            <a:r>
+              <a:t>      'ttl_minutes': ttlMinutes,        // مهلة حجز الدواء</a:t>
+            </a:r>
+          </a:p>
+          <a:p>
+            <a:pPr algn="l">
+              <a:defRPr sz="919">
                 <a:solidFill>
                   <a:srgbClr val="38BDF8"/>
                 </a:solidFill>
@@ -9553,7 +9618,7 @@
           </a:p>
           <a:p>
             <a:pPr algn="l">
-              <a:defRPr sz="1000">
+              <a:defRPr sz="919">
                 <a:solidFill>
                   <a:srgbClr val="38BDF8"/>
                 </a:solidFill>
@@ -9566,17 +9631,17 @@
           </a:p>
           <a:p>
             <a:pPr algn="l">
-              <a:defRPr sz="1000">
-                <a:solidFill>
-                  <a:srgbClr val="38BDF8"/>
-                </a:solidFill>
-                <a:latin typeface="Consolas"/>
-              </a:defRPr>
-            </a:pPr>
-          </a:p>
-          <a:p>
-            <a:pPr algn="l">
-              <a:defRPr sz="1000">
+              <a:defRPr sz="919">
+                <a:solidFill>
+                  <a:srgbClr val="38BDF8"/>
+                </a:solidFill>
+                <a:latin typeface="Consolas"/>
+              </a:defRPr>
+            </a:pPr>
+          </a:p>
+          <a:p>
+            <a:pPr algn="l">
+              <a:defRPr sz="919">
                 <a:solidFill>
                   <a:srgbClr val="F472B6"/>
                 </a:solidFill>
@@ -9589,7 +9654,7 @@
           </a:p>
           <a:p>
             <a:pPr algn="l">
-              <a:defRPr sz="1000">
+              <a:defRPr sz="919">
                 <a:solidFill>
                   <a:srgbClr val="38BDF8"/>
                 </a:solidFill>
@@ -9602,7 +9667,7 @@
           </a:p>
           <a:p>
             <a:pPr algn="l">
-              <a:defRPr sz="1000">
+              <a:defRPr sz="919">
                 <a:solidFill>
                   <a:srgbClr val="38BDF8"/>
                 </a:solidFill>
@@ -9615,33 +9680,33 @@
           </a:p>
           <a:p>
             <a:pPr algn="l">
-              <a:defRPr sz="1000">
-                <a:solidFill>
-                  <a:srgbClr val="38BDF8"/>
-                </a:solidFill>
-                <a:latin typeface="Consolas"/>
-              </a:defRPr>
-            </a:pPr>
-            <a:r>
-              <a:t>    _cachedReservations.insert(0, created);</a:t>
-            </a:r>
-          </a:p>
-          <a:p>
-            <a:pPr algn="l">
-              <a:defRPr sz="1000">
-                <a:solidFill>
-                  <a:srgbClr val="38BDF8"/>
-                </a:solidFill>
-                <a:latin typeface="Consolas"/>
-              </a:defRPr>
-            </a:pPr>
-            <a:r>
-              <a:t>    notifyListeners();</a:t>
-            </a:r>
-          </a:p>
-          <a:p>
-            <a:pPr algn="l">
-              <a:defRPr sz="1000">
+              <a:defRPr sz="919">
+                <a:solidFill>
+                  <a:srgbClr val="38BDF8"/>
+                </a:solidFill>
+                <a:latin typeface="Consolas"/>
+              </a:defRPr>
+            </a:pPr>
+            <a:r>
+              <a:t>    _cachedReservations.insert(0, created); // تخزين التذكرة محلياً</a:t>
+            </a:r>
+          </a:p>
+          <a:p>
+            <a:pPr algn="l">
+              <a:defRPr sz="919">
+                <a:solidFill>
+                  <a:srgbClr val="38BDF8"/>
+                </a:solidFill>
+                <a:latin typeface="Consolas"/>
+              </a:defRPr>
+            </a:pPr>
+            <a:r>
+              <a:t>    notifyListeners(); // بدء مؤقت العد التنازلي الحي</a:t>
+            </a:r>
+          </a:p>
+          <a:p>
+            <a:pPr algn="l">
+              <a:defRPr sz="919">
                 <a:solidFill>
                   <a:srgbClr val="F472B6"/>
                 </a:solidFill>
@@ -9654,7 +9719,7 @@
           </a:p>
           <a:p>
             <a:pPr algn="l">
-              <a:defRPr sz="1000">
+              <a:defRPr sz="919">
                 <a:solidFill>
                   <a:srgbClr val="38BDF8"/>
                 </a:solidFill>
@@ -9667,7 +9732,7 @@
           </a:p>
           <a:p>
             <a:pPr algn="l">
-              <a:defRPr sz="1000">
+              <a:defRPr sz="919">
                 <a:solidFill>
                   <a:srgbClr val="38BDF8"/>
                 </a:solidFill>
@@ -9680,7 +9745,7 @@
           </a:p>
           <a:p>
             <a:pPr algn="l">
-              <a:defRPr sz="1000">
+              <a:defRPr sz="919">
                 <a:solidFill>
                   <a:srgbClr val="38BDF8"/>
                 </a:solidFill>
@@ -9782,8 +9847,8 @@
         </p:nvSpPr>
         <p:spPr>
           <a:xfrm>
-            <a:off x="6400800" y="1801368"/>
-            <a:ext cx="4846320" cy="4251959"/>
+            <a:off x="6400800" y="1783080"/>
+            <a:ext cx="4846320" cy="4279392"/>
           </a:xfrm>
           <a:prstGeom prst="rect">
             <a:avLst/>
@@ -9797,7 +9862,7 @@
           <a:lstStyle/>
           <a:p>
             <a:pPr algn="l">
-              <a:defRPr sz="1000">
+              <a:defRPr sz="919">
                 <a:solidFill>
                   <a:srgbClr val="94A3B8"/>
                 </a:solidFill>
@@ -9810,7 +9875,7 @@
           </a:p>
           <a:p>
             <a:pPr algn="l">
-              <a:defRPr sz="1000">
+              <a:defRPr sz="919">
                 <a:solidFill>
                   <a:srgbClr val="F472B6"/>
                 </a:solidFill>
@@ -9823,7 +9888,20 @@
           </a:p>
           <a:p>
             <a:pPr algn="l">
-              <a:defRPr sz="1000">
+              <a:defRPr sz="919">
+                <a:solidFill>
+                  <a:srgbClr val="94A3B8"/>
+                </a:solidFill>
+                <a:latin typeface="Consolas"/>
+              </a:defRPr>
+            </a:pPr>
+            <a:r>
+              <a:t>    // تنفيذ الحجز داخل معاملة ذرية متكاملة (ACID Transaction)</a:t>
+            </a:r>
+          </a:p>
+          <a:p>
+            <a:pPr algn="l">
+              <a:defRPr sz="919">
                 <a:solidFill>
                   <a:srgbClr val="F472B6"/>
                 </a:solidFill>
@@ -9836,7 +9914,7 @@
           </a:p>
           <a:p>
             <a:pPr algn="l">
-              <a:defRPr sz="1000">
+              <a:defRPr sz="919">
                 <a:solidFill>
                   <a:srgbClr val="94A3B8"/>
                 </a:solidFill>
@@ -9844,12 +9922,12 @@
               </a:defRPr>
             </a:pPr>
             <a:r>
-              <a:t>        // 1. قفل الصف تشاؤمياً لمنع المعاملات المتزامنة</a:t>
-            </a:r>
-          </a:p>
-          <a:p>
-            <a:pPr algn="l">
-              <a:defRPr sz="1000">
+              <a:t>        // 1. قفل الصف تشاؤمياً لمنع تنافس مريضين على نفس العلبة</a:t>
+            </a:r>
+          </a:p>
+          <a:p>
+            <a:pPr algn="l">
+              <a:defRPr sz="919">
                 <a:solidFill>
                   <a:srgbClr val="38BDF8"/>
                 </a:solidFill>
@@ -9862,20 +9940,20 @@
           </a:p>
           <a:p>
             <a:pPr algn="l">
-              <a:defRPr sz="1000">
-                <a:solidFill>
-                  <a:srgbClr val="38BDF8"/>
-                </a:solidFill>
-                <a:latin typeface="Consolas"/>
-              </a:defRPr>
-            </a:pPr>
-            <a:r>
-              <a:t>            -&gt;lockForUpdate()</a:t>
-            </a:r>
-          </a:p>
-          <a:p>
-            <a:pPr algn="l">
-              <a:defRPr sz="1000">
+              <a:defRPr sz="919">
+                <a:solidFill>
+                  <a:srgbClr val="38BDF8"/>
+                </a:solidFill>
+                <a:latin typeface="Consolas"/>
+              </a:defRPr>
+            </a:pPr>
+            <a:r>
+              <a:t>            -&gt;lockForUpdate() // قفل حصري في InnoDB يمنع Race Condition</a:t>
+            </a:r>
+          </a:p>
+          <a:p>
+            <a:pPr algn="l">
+              <a:defRPr sz="919">
                 <a:solidFill>
                   <a:srgbClr val="38BDF8"/>
                 </a:solidFill>
@@ -9888,17 +9966,17 @@
           </a:p>
           <a:p>
             <a:pPr algn="l">
-              <a:defRPr sz="1000">
-                <a:solidFill>
-                  <a:srgbClr val="38BDF8"/>
-                </a:solidFill>
-                <a:latin typeface="Consolas"/>
-              </a:defRPr>
-            </a:pPr>
-          </a:p>
-          <a:p>
-            <a:pPr algn="l">
-              <a:defRPr sz="1000">
+              <a:defRPr sz="919">
+                <a:solidFill>
+                  <a:srgbClr val="38BDF8"/>
+                </a:solidFill>
+                <a:latin typeface="Consolas"/>
+              </a:defRPr>
+            </a:pPr>
+          </a:p>
+          <a:p>
+            <a:pPr algn="l">
+              <a:defRPr sz="919">
                 <a:solidFill>
                   <a:srgbClr val="94A3B8"/>
                 </a:solidFill>
@@ -9906,12 +9984,12 @@
               </a:defRPr>
             </a:pPr>
             <a:r>
-              <a:t>        // 2. التحقق الذري من الرصيد الفعلي</a:t>
-            </a:r>
-          </a:p>
-          <a:p>
-            <a:pPr algn="l">
-              <a:defRPr sz="1000">
+              <a:t>        // 2. التحقق الذري من توفر الرصيد الفعلي</a:t>
+            </a:r>
+          </a:p>
+          <a:p>
+            <a:pPr algn="l">
+              <a:defRPr sz="919">
                 <a:solidFill>
                   <a:srgbClr val="F472B6"/>
                 </a:solidFill>
@@ -9924,7 +10002,7 @@
           </a:p>
           <a:p>
             <a:pPr algn="l">
-              <a:defRPr sz="1000">
+              <a:defRPr sz="919">
                 <a:solidFill>
                   <a:srgbClr val="38BDF8"/>
                 </a:solidFill>
@@ -9937,7 +10015,7 @@
           </a:p>
           <a:p>
             <a:pPr algn="l">
-              <a:defRPr sz="1000">
+              <a:defRPr sz="919">
                 <a:solidFill>
                   <a:srgbClr val="38BDF8"/>
                 </a:solidFill>
@@ -9950,17 +10028,17 @@
           </a:p>
           <a:p>
             <a:pPr algn="l">
-              <a:defRPr sz="1000">
-                <a:solidFill>
-                  <a:srgbClr val="38BDF8"/>
-                </a:solidFill>
-                <a:latin typeface="Consolas"/>
-              </a:defRPr>
-            </a:pPr>
-          </a:p>
-          <a:p>
-            <a:pPr algn="l">
-              <a:defRPr sz="1000">
+              <a:defRPr sz="919">
+                <a:solidFill>
+                  <a:srgbClr val="38BDF8"/>
+                </a:solidFill>
+                <a:latin typeface="Consolas"/>
+              </a:defRPr>
+            </a:pPr>
+          </a:p>
+          <a:p>
+            <a:pPr algn="l">
+              <a:defRPr sz="919">
                 <a:solidFill>
                   <a:srgbClr val="94A3B8"/>
                 </a:solidFill>
@@ -9968,12 +10046,12 @@
               </a:defRPr>
             </a:pPr>
             <a:r>
-              <a:t>        // 3. الخصم الآمن وتحديث الحالة</a:t>
-            </a:r>
-          </a:p>
-          <a:p>
-            <a:pPr algn="l">
-              <a:defRPr sz="1000">
+              <a:t>        // 3. الخصم الآمن وتحديث حالة الصنف تلقائياً</a:t>
+            </a:r>
+          </a:p>
+          <a:p>
+            <a:pPr algn="l">
+              <a:defRPr sz="919">
                 <a:solidFill>
                   <a:srgbClr val="38BDF8"/>
                 </a:solidFill>
@@ -9986,7 +10064,7 @@
           </a:p>
           <a:p>
             <a:pPr algn="l">
-              <a:defRPr sz="1000">
+              <a:defRPr sz="919">
                 <a:solidFill>
                   <a:srgbClr val="F472B6"/>
                 </a:solidFill>
@@ -9999,7 +10077,7 @@
           </a:p>
           <a:p>
             <a:pPr algn="l">
-              <a:defRPr sz="1000">
+              <a:defRPr sz="919">
                 <a:solidFill>
                   <a:srgbClr val="38BDF8"/>
                 </a:solidFill>
@@ -10012,7 +10090,7 @@
           </a:p>
           <a:p>
             <a:pPr algn="l">
-              <a:defRPr sz="1000">
+              <a:defRPr sz="919">
                 <a:solidFill>
                   <a:srgbClr val="38BDF8"/>
                 </a:solidFill>
@@ -10025,17 +10103,17 @@
           </a:p>
           <a:p>
             <a:pPr algn="l">
-              <a:defRPr sz="1000">
-                <a:solidFill>
-                  <a:srgbClr val="38BDF8"/>
-                </a:solidFill>
-                <a:latin typeface="Consolas"/>
-              </a:defRPr>
-            </a:pPr>
-          </a:p>
-          <a:p>
-            <a:pPr algn="l">
-              <a:defRPr sz="1000">
+              <a:defRPr sz="919">
+                <a:solidFill>
+                  <a:srgbClr val="38BDF8"/>
+                </a:solidFill>
+                <a:latin typeface="Consolas"/>
+              </a:defRPr>
+            </a:pPr>
+          </a:p>
+          <a:p>
+            <a:pPr algn="l">
+              <a:defRPr sz="919">
                 <a:solidFill>
                   <a:srgbClr val="94A3B8"/>
                 </a:solidFill>
@@ -10043,12 +10121,12 @@
               </a:defRPr>
             </a:pPr>
             <a:r>
-              <a:t>        // 4. إنشاء الحجز وتحديد انتهاء الصلاحية 30 دقيقة</a:t>
-            </a:r>
-          </a:p>
-          <a:p>
-            <a:pPr algn="l">
-              <a:defRPr sz="1000">
+              <a:t>        // 4. إنشاء سجل الحجز برمز فريد ومؤقت صلاحية 30 دقيقة</a:t>
+            </a:r>
+          </a:p>
+          <a:p>
+            <a:pPr algn="l">
+              <a:defRPr sz="919">
                 <a:solidFill>
                   <a:srgbClr val="F472B6"/>
                 </a:solidFill>
@@ -10061,7 +10139,7 @@
           </a:p>
           <a:p>
             <a:pPr algn="l">
-              <a:defRPr sz="1000">
+              <a:defRPr sz="919">
                 <a:solidFill>
                   <a:srgbClr val="38BDF8"/>
                 </a:solidFill>
@@ -10074,7 +10152,7 @@
           </a:p>
           <a:p>
             <a:pPr algn="l">
-              <a:defRPr sz="1000">
+              <a:defRPr sz="919">
                 <a:solidFill>
                   <a:srgbClr val="38BDF8"/>
                 </a:solidFill>
@@ -10087,7 +10165,7 @@
           </a:p>
           <a:p>
             <a:pPr algn="l">
-              <a:defRPr sz="1000">
+              <a:defRPr sz="919">
                 <a:solidFill>
                   <a:srgbClr val="38BDF8"/>
                 </a:solidFill>
@@ -10100,7 +10178,7 @@
           </a:p>
           <a:p>
             <a:pPr algn="l">
-              <a:defRPr sz="1000">
+              <a:defRPr sz="919">
                 <a:solidFill>
                   <a:srgbClr val="38BDF8"/>
                 </a:solidFill>
@@ -10113,7 +10191,7 @@
           </a:p>
           <a:p>
             <a:pPr algn="l">
-              <a:defRPr sz="1000">
+              <a:defRPr sz="919">
                 <a:solidFill>
                   <a:srgbClr val="38BDF8"/>
                 </a:solidFill>
@@ -10126,7 +10204,7 @@
           </a:p>
           <a:p>
             <a:pPr algn="l">
-              <a:defRPr sz="1000">
+              <a:defRPr sz="919">
                 <a:solidFill>
                   <a:srgbClr val="38BDF8"/>
                 </a:solidFill>
@@ -10442,8 +10520,8 @@
         </p:nvSpPr>
         <p:spPr>
           <a:xfrm>
-            <a:off x="914400" y="1801368"/>
-            <a:ext cx="4846320" cy="4251959"/>
+            <a:off x="914400" y="1783080"/>
+            <a:ext cx="4846320" cy="4279392"/>
           </a:xfrm>
           <a:prstGeom prst="rect">
             <a:avLst/>
@@ -10457,7 +10535,7 @@
           <a:lstStyle/>
           <a:p>
             <a:pPr algn="l">
-              <a:defRPr sz="1000">
+              <a:defRPr sz="919">
                 <a:solidFill>
                   <a:srgbClr val="94A3B8"/>
                 </a:solidFill>
@@ -10470,7 +10548,20 @@
           </a:p>
           <a:p>
             <a:pPr algn="l">
-              <a:defRPr sz="1000">
+              <a:defRPr sz="919">
+                <a:solidFill>
+                  <a:srgbClr val="94A3B8"/>
+                </a:solidFill>
+                <a:latin typeface="Consolas"/>
+              </a:defRPr>
+            </a:pPr>
+            <a:r>
+              <a:t>// تمرير إحداثيات GPS الحالية ونصف قطر البحث في الـ Query String</a:t>
+            </a:r>
+          </a:p>
+          <a:p>
+            <a:pPr algn="l">
+              <a:defRPr sz="919">
                 <a:solidFill>
                   <a:srgbClr val="38BDF8"/>
                 </a:solidFill>
@@ -10483,7 +10574,7 @@
           </a:p>
           <a:p>
             <a:pPr algn="l">
-              <a:defRPr sz="1000">
+              <a:defRPr sz="919">
                 <a:solidFill>
                   <a:srgbClr val="38BDF8"/>
                 </a:solidFill>
@@ -10496,7 +10587,7 @@
           </a:p>
           <a:p>
             <a:pPr algn="l">
-              <a:defRPr sz="1000">
+              <a:defRPr sz="919">
                 <a:solidFill>
                   <a:srgbClr val="F472B6"/>
                 </a:solidFill>
@@ -10509,7 +10600,7 @@
           </a:p>
           <a:p>
             <a:pPr algn="l">
-              <a:defRPr sz="1000">
+              <a:defRPr sz="919">
                 <a:solidFill>
                   <a:srgbClr val="38BDF8"/>
                 </a:solidFill>
@@ -10522,7 +10613,7 @@
           </a:p>
           <a:p>
             <a:pPr algn="l">
-              <a:defRPr sz="1000">
+              <a:defRPr sz="919">
                 <a:solidFill>
                   <a:srgbClr val="F472B6"/>
                 </a:solidFill>
@@ -10530,12 +10621,12 @@
               </a:defRPr>
             </a:pPr>
             <a:r>
-              <a:t>    if (query != null) 'q': query,</a:t>
-            </a:r>
-          </a:p>
-          <a:p>
-            <a:pPr algn="l">
-              <a:defRPr sz="1000">
+              <a:t>    if (query != null) 'q': query,                     // اسم الدواء</a:t>
+            </a:r>
+          </a:p>
+          <a:p>
+            <a:pPr algn="l">
+              <a:defRPr sz="919">
                 <a:solidFill>
                   <a:srgbClr val="F472B6"/>
                 </a:solidFill>
@@ -10543,12 +10634,12 @@
               </a:defRPr>
             </a:pPr>
             <a:r>
-              <a:t>    if (latitude != null) 'lat': latitude.toString(),</a:t>
-            </a:r>
-          </a:p>
-          <a:p>
-            <a:pPr algn="l">
-              <a:defRPr sz="1000">
+              <a:t>    if (latitude != null) 'lat': latitude.toString(),  // خط العرض</a:t>
+            </a:r>
+          </a:p>
+          <a:p>
+            <a:pPr algn="l">
+              <a:defRPr sz="919">
                 <a:solidFill>
                   <a:srgbClr val="F472B6"/>
                 </a:solidFill>
@@ -10556,25 +10647,25 @@
               </a:defRPr>
             </a:pPr>
             <a:r>
-              <a:t>    if (longitude != null) 'lng': longitude.toString(),</a:t>
-            </a:r>
-          </a:p>
-          <a:p>
-            <a:pPr algn="l">
-              <a:defRPr sz="1000">
-                <a:solidFill>
-                  <a:srgbClr val="38BDF8"/>
-                </a:solidFill>
-                <a:latin typeface="Consolas"/>
-              </a:defRPr>
-            </a:pPr>
-            <a:r>
-              <a:t>    'radius': radiusKm.toString(),</a:t>
-            </a:r>
-          </a:p>
-          <a:p>
-            <a:pPr algn="l">
-              <a:defRPr sz="1000">
+              <a:t>    if (longitude != null) 'lng': longitude.toString(),// خط الطول</a:t>
+            </a:r>
+          </a:p>
+          <a:p>
+            <a:pPr algn="l">
+              <a:defRPr sz="919">
+                <a:solidFill>
+                  <a:srgbClr val="38BDF8"/>
+                </a:solidFill>
+                <a:latin typeface="Consolas"/>
+              </a:defRPr>
+            </a:pPr>
+            <a:r>
+              <a:t>    'radius': radiusKm.toString(),                     // نصف القطر (كم)</a:t>
+            </a:r>
+          </a:p>
+          <a:p>
+            <a:pPr algn="l">
+              <a:defRPr sz="919">
                 <a:solidFill>
                   <a:srgbClr val="38BDF8"/>
                 </a:solidFill>
@@ -10587,7 +10678,7 @@
           </a:p>
           <a:p>
             <a:pPr algn="l">
-              <a:defRPr sz="1000">
+              <a:defRPr sz="919">
                 <a:solidFill>
                   <a:srgbClr val="38BDF8"/>
                 </a:solidFill>
@@ -10600,7 +10691,7 @@
           </a:p>
           <a:p>
             <a:pPr algn="l">
-              <a:defRPr sz="1000">
+              <a:defRPr sz="919">
                 <a:solidFill>
                   <a:srgbClr val="38BDF8"/>
                 </a:solidFill>
@@ -10613,7 +10704,7 @@
           </a:p>
           <a:p>
             <a:pPr algn="l">
-              <a:defRPr sz="1000">
+              <a:defRPr sz="919">
                 <a:solidFill>
                   <a:srgbClr val="F472B6"/>
                 </a:solidFill>
@@ -10626,7 +10717,7 @@
           </a:p>
           <a:p>
             <a:pPr algn="l">
-              <a:defRPr sz="1000">
+              <a:defRPr sz="919">
                 <a:solidFill>
                   <a:srgbClr val="38BDF8"/>
                 </a:solidFill>
@@ -10639,7 +10730,20 @@
           </a:p>
           <a:p>
             <a:pPr algn="l">
-              <a:defRPr sz="1000">
+              <a:defRPr sz="919">
+                <a:solidFill>
+                  <a:srgbClr val="94A3B8"/>
+                </a:solidFill>
+                <a:latin typeface="Consolas"/>
+              </a:defRPr>
+            </a:pPr>
+            <a:r>
+              <a:t>  // تحويل استجابة الـ JSON لقائمة صيدليات مرتبة بالأمتار</a:t>
+            </a:r>
+          </a:p>
+          <a:p>
+            <a:pPr algn="l">
+              <a:defRPr sz="919">
                 <a:solidFill>
                   <a:srgbClr val="F472B6"/>
                 </a:solidFill>
@@ -10652,7 +10756,7 @@
           </a:p>
           <a:p>
             <a:pPr algn="l">
-              <a:defRPr sz="1000">
+              <a:defRPr sz="919">
                 <a:solidFill>
                   <a:srgbClr val="38BDF8"/>
                 </a:solidFill>
@@ -10665,7 +10769,7 @@
           </a:p>
           <a:p>
             <a:pPr algn="l">
-              <a:defRPr sz="1000">
+              <a:defRPr sz="919">
                 <a:solidFill>
                   <a:srgbClr val="38BDF8"/>
                 </a:solidFill>
@@ -10678,7 +10782,7 @@
           </a:p>
           <a:p>
             <a:pPr algn="l">
-              <a:defRPr sz="1000">
+              <a:defRPr sz="919">
                 <a:solidFill>
                   <a:srgbClr val="38BDF8"/>
                 </a:solidFill>
@@ -10780,8 +10884,8 @@
         </p:nvSpPr>
         <p:spPr>
           <a:xfrm>
-            <a:off x="6400800" y="1801368"/>
-            <a:ext cx="4846320" cy="4251959"/>
+            <a:off x="6400800" y="1783080"/>
+            <a:ext cx="4846320" cy="4279392"/>
           </a:xfrm>
           <a:prstGeom prst="rect">
             <a:avLst/>
@@ -10795,7 +10899,7 @@
           <a:lstStyle/>
           <a:p>
             <a:pPr algn="l">
-              <a:defRPr sz="1000">
+              <a:defRPr sz="919">
                 <a:solidFill>
                   <a:srgbClr val="94A3B8"/>
                 </a:solidFill>
@@ -10808,7 +10912,20 @@
           </a:p>
           <a:p>
             <a:pPr algn="l">
-              <a:defRPr sz="1000">
+              <a:defRPr sz="919">
+                <a:solidFill>
+                  <a:srgbClr val="94A3B8"/>
+                </a:solidFill>
+                <a:latin typeface="Consolas"/>
+              </a:defRPr>
+            </a:pPr>
+            <a:r>
+              <a:t>// تطبيق خوارزمية هافرسين الرياضية لحساب المسافة الكروية الحقيقية</a:t>
+            </a:r>
+          </a:p>
+          <a:p>
+            <a:pPr algn="l">
+              <a:defRPr sz="919">
                 <a:solidFill>
                   <a:srgbClr val="F472B6"/>
                 </a:solidFill>
@@ -10821,46 +10938,59 @@
           </a:p>
           <a:p>
             <a:pPr algn="l">
-              <a:defRPr sz="1000">
-                <a:solidFill>
-                  <a:srgbClr val="38BDF8"/>
-                </a:solidFill>
-                <a:latin typeface="Consolas"/>
-              </a:defRPr>
-            </a:pPr>
-            <a:r>
-              <a:t>    $earthRadiusKm = 6371.0; // نصف قطر الأرض الكروي</a:t>
-            </a:r>
-          </a:p>
-          <a:p>
-            <a:pPr algn="l">
-              <a:defRPr sz="1000">
-                <a:solidFill>
-                  <a:srgbClr val="38BDF8"/>
-                </a:solidFill>
-                <a:latin typeface="Consolas"/>
-              </a:defRPr>
-            </a:pPr>
-            <a:r>
-              <a:t>    $dLat = deg2rad($lat2 - $lat1);</a:t>
-            </a:r>
-          </a:p>
-          <a:p>
-            <a:pPr algn="l">
-              <a:defRPr sz="1000">
-                <a:solidFill>
-                  <a:srgbClr val="38BDF8"/>
-                </a:solidFill>
-                <a:latin typeface="Consolas"/>
-              </a:defRPr>
-            </a:pPr>
-            <a:r>
-              <a:t>    $dLon = deg2rad($lon2 - $lon1);</a:t>
-            </a:r>
-          </a:p>
-          <a:p>
-            <a:pPr algn="l">
-              <a:defRPr sz="1000">
+              <a:defRPr sz="919">
+                <a:solidFill>
+                  <a:srgbClr val="38BDF8"/>
+                </a:solidFill>
+                <a:latin typeface="Consolas"/>
+              </a:defRPr>
+            </a:pPr>
+            <a:r>
+              <a:t>    $earthRadiusKm = 6371.0; // نصف قطر كوكب الأرض بالكيلومتر</a:t>
+            </a:r>
+          </a:p>
+          <a:p>
+            <a:pPr algn="l">
+              <a:defRPr sz="919">
+                <a:solidFill>
+                  <a:srgbClr val="38BDF8"/>
+                </a:solidFill>
+                <a:latin typeface="Consolas"/>
+              </a:defRPr>
+            </a:pPr>
+            <a:r>
+              <a:t>    $dLat = deg2rad($lat2 - $lat1); // تحويل فرق درجات العرض إلى راديان</a:t>
+            </a:r>
+          </a:p>
+          <a:p>
+            <a:pPr algn="l">
+              <a:defRPr sz="919">
+                <a:solidFill>
+                  <a:srgbClr val="38BDF8"/>
+                </a:solidFill>
+                <a:latin typeface="Consolas"/>
+              </a:defRPr>
+            </a:pPr>
+            <a:r>
+              <a:t>    $dLon = deg2rad($lon2 - $lon1); // تحويل فرق درجات الطول إلى راديان</a:t>
+            </a:r>
+          </a:p>
+          <a:p>
+            <a:pPr algn="l">
+              <a:defRPr sz="919">
+                <a:solidFill>
+                  <a:srgbClr val="94A3B8"/>
+                </a:solidFill>
+                <a:latin typeface="Consolas"/>
+              </a:defRPr>
+            </a:pPr>
+            <a:r>
+              <a:t>    // معادلة هافرسين المثلثية الكروية</a:t>
+            </a:r>
+          </a:p>
+          <a:p>
+            <a:pPr algn="l">
+              <a:defRPr sz="919">
                 <a:solidFill>
                   <a:srgbClr val="38BDF8"/>
                 </a:solidFill>
@@ -10873,7 +11003,7 @@
           </a:p>
           <a:p>
             <a:pPr algn="l">
-              <a:defRPr sz="1000">
+              <a:defRPr sz="919">
                 <a:solidFill>
                   <a:srgbClr val="38BDF8"/>
                 </a:solidFill>
@@ -10886,7 +11016,7 @@
           </a:p>
           <a:p>
             <a:pPr algn="l">
-              <a:defRPr sz="1000">
+              <a:defRPr sz="919">
                 <a:solidFill>
                   <a:srgbClr val="38BDF8"/>
                 </a:solidFill>
@@ -10899,7 +11029,7 @@
           </a:p>
           <a:p>
             <a:pPr algn="l">
-              <a:defRPr sz="1000">
+              <a:defRPr sz="919">
                 <a:solidFill>
                   <a:srgbClr val="38BDF8"/>
                 </a:solidFill>
@@ -10912,7 +11042,7 @@
           </a:p>
           <a:p>
             <a:pPr algn="l">
-              <a:defRPr sz="1000">
+              <a:defRPr sz="919">
                 <a:solidFill>
                   <a:srgbClr val="F472B6"/>
                 </a:solidFill>
@@ -10920,12 +11050,12 @@
               </a:defRPr>
             </a:pPr>
             <a:r>
-              <a:t>    return $earthRadiusKm * $c; // المسافة بالكيلومتر</a:t>
-            </a:r>
-          </a:p>
-          <a:p>
-            <a:pPr algn="l">
-              <a:defRPr sz="1000">
+              <a:t>    return $earthRadiusKm * $c; // الناتج: المسافة الواقعية المستقيمة</a:t>
+            </a:r>
+          </a:p>
+          <a:p>
+            <a:pPr algn="l">
+              <a:defRPr sz="919">
                 <a:solidFill>
                   <a:srgbClr val="38BDF8"/>
                 </a:solidFill>
@@ -10938,17 +11068,17 @@
           </a:p>
           <a:p>
             <a:pPr algn="l">
-              <a:defRPr sz="1000">
-                <a:solidFill>
-                  <a:srgbClr val="38BDF8"/>
-                </a:solidFill>
-                <a:latin typeface="Consolas"/>
-              </a:defRPr>
-            </a:pPr>
-          </a:p>
-          <a:p>
-            <a:pPr algn="l">
-              <a:defRPr sz="1000">
+              <a:defRPr sz="919">
+                <a:solidFill>
+                  <a:srgbClr val="38BDF8"/>
+                </a:solidFill>
+                <a:latin typeface="Consolas"/>
+              </a:defRPr>
+            </a:pPr>
+          </a:p>
+          <a:p>
+            <a:pPr algn="l">
+              <a:defRPr sz="919">
                 <a:solidFill>
                   <a:srgbClr val="94A3B8"/>
                 </a:solidFill>
@@ -10956,12 +11086,12 @@
               </a:defRPr>
             </a:pPr>
             <a:r>
-              <a:t>// تصفية الصيدليات وترتيبها من الأقرب إلى الأبعد</a:t>
-            </a:r>
-          </a:p>
-          <a:p>
-            <a:pPr algn="l">
-              <a:defRPr sz="1000">
+              <a:t>// تصفية الصيدليات ضمن النطاق وفرز النتائج من الأقرب إلى الأبعد للمريض</a:t>
+            </a:r>
+          </a:p>
+          <a:p>
+            <a:pPr algn="l">
+              <a:defRPr sz="919">
                 <a:solidFill>
                   <a:srgbClr val="F472B6"/>
                 </a:solidFill>
@@ -10974,7 +11104,7 @@
           </a:p>
           <a:p>
             <a:pPr algn="l">
-              <a:defRPr sz="1000">
+              <a:defRPr sz="919">
                 <a:solidFill>
                   <a:srgbClr val="F472B6"/>
                 </a:solidFill>
@@ -10982,20 +11112,20 @@
               </a:defRPr>
             </a:pPr>
             <a:r>
-              <a:t>    return $item-&gt;distance_km &lt;= $radiusKm;</a:t>
-            </a:r>
-          </a:p>
-          <a:p>
-            <a:pPr algn="l">
-              <a:defRPr sz="1000">
-                <a:solidFill>
-                  <a:srgbClr val="38BDF8"/>
-                </a:solidFill>
-                <a:latin typeface="Consolas"/>
-              </a:defRPr>
-            </a:pPr>
-            <a:r>
-              <a:t>})-&gt;sortBy('distance_km')-&gt;values();</a:t>
+              <a:t>    return $item-&gt;distance_km &lt;= $radiusKm; // استبعاد الصيدليات البعيدة</a:t>
+            </a:r>
+          </a:p>
+          <a:p>
+            <a:pPr algn="l">
+              <a:defRPr sz="919">
+                <a:solidFill>
+                  <a:srgbClr val="38BDF8"/>
+                </a:solidFill>
+                <a:latin typeface="Consolas"/>
+              </a:defRPr>
+            </a:pPr>
+            <a:r>
+              <a:t>})-&gt;sortBy('distance_km')-&gt;values();         // فرز تصاعدي حسب المسافة</a:t>
             </a:r>
           </a:p>
         </p:txBody>
@@ -11303,8 +11433,8 @@
         </p:nvSpPr>
         <p:spPr>
           <a:xfrm>
-            <a:off x="914400" y="1801368"/>
-            <a:ext cx="4846320" cy="4251959"/>
+            <a:off x="914400" y="1783080"/>
+            <a:ext cx="4846320" cy="4279392"/>
           </a:xfrm>
           <a:prstGeom prst="rect">
             <a:avLst/>
@@ -11318,7 +11448,7 @@
           <a:lstStyle/>
           <a:p>
             <a:pPr algn="l">
-              <a:defRPr sz="1000">
+              <a:defRPr sz="919">
                 <a:solidFill>
                   <a:srgbClr val="94A3B8"/>
                 </a:solidFill>
@@ -11331,7 +11461,20 @@
           </a:p>
           <a:p>
             <a:pPr algn="l">
-              <a:defRPr sz="1000">
+              <a:defRPr sz="919">
+                <a:solidFill>
+                  <a:srgbClr val="94A3B8"/>
+                </a:solidFill>
+                <a:latin typeface="Consolas"/>
+              </a:defRPr>
+            </a:pPr>
+            <a:r>
+              <a:t>// استطلاع دوري لحالة الحجز بالخلفية لاقتناص تأكيد الصيدلي فوراً</a:t>
+            </a:r>
+          </a:p>
+          <a:p>
+            <a:pPr algn="l">
+              <a:defRPr sz="919">
                 <a:solidFill>
                   <a:srgbClr val="38BDF8"/>
                 </a:solidFill>
@@ -11344,7 +11487,7 @@
           </a:p>
           <a:p>
             <a:pPr algn="l">
-              <a:defRPr sz="1000">
+              <a:defRPr sz="919">
                 <a:solidFill>
                   <a:srgbClr val="F472B6"/>
                 </a:solidFill>
@@ -11357,7 +11500,20 @@
           </a:p>
           <a:p>
             <a:pPr algn="l">
-              <a:defRPr sz="1000">
+              <a:defRPr sz="919">
+                <a:solidFill>
+                  <a:srgbClr val="94A3B8"/>
+                </a:solidFill>
+                <a:latin typeface="Consolas"/>
+              </a:defRPr>
+            </a:pPr>
+            <a:r>
+              <a:t>    // استعلام الخادم عن الحالة الحالية للتذكرة بواسطة كود الحجز</a:t>
+            </a:r>
+          </a:p>
+          <a:p>
+            <a:pPr algn="l">
+              <a:defRPr sz="919">
                 <a:solidFill>
                   <a:srgbClr val="F472B6"/>
                 </a:solidFill>
@@ -11370,7 +11526,7 @@
           </a:p>
           <a:p>
             <a:pPr algn="l">
-              <a:defRPr sz="1000">
+              <a:defRPr sz="919">
                 <a:solidFill>
                   <a:srgbClr val="38BDF8"/>
                 </a:solidFill>
@@ -11383,17 +11539,17 @@
           </a:p>
           <a:p>
             <a:pPr algn="l">
-              <a:defRPr sz="1000">
-                <a:solidFill>
-                  <a:srgbClr val="38BDF8"/>
-                </a:solidFill>
-                <a:latin typeface="Consolas"/>
-              </a:defRPr>
-            </a:pPr>
-          </a:p>
-          <a:p>
-            <a:pPr algn="l">
-              <a:defRPr sz="1000">
+              <a:defRPr sz="919">
+                <a:solidFill>
+                  <a:srgbClr val="38BDF8"/>
+                </a:solidFill>
+                <a:latin typeface="Consolas"/>
+              </a:defRPr>
+            </a:pPr>
+          </a:p>
+          <a:p>
+            <a:pPr algn="l">
+              <a:defRPr sz="919">
                 <a:solidFill>
                   <a:srgbClr val="F472B6"/>
                 </a:solidFill>
@@ -11406,7 +11562,20 @@
           </a:p>
           <a:p>
             <a:pPr algn="l">
-              <a:defRPr sz="1000">
+              <a:defRPr sz="919">
+                <a:solidFill>
+                  <a:srgbClr val="94A3B8"/>
+                </a:solidFill>
+                <a:latin typeface="Consolas"/>
+              </a:defRPr>
+            </a:pPr>
+            <a:r>
+              <a:t>      // التحقق مما إذا تم تأكيد تسليم الدواء بالويب</a:t>
+            </a:r>
+          </a:p>
+          <a:p>
+            <a:pPr algn="l">
+              <a:defRPr sz="919">
                 <a:solidFill>
                   <a:srgbClr val="38BDF8"/>
                 </a:solidFill>
@@ -11419,7 +11588,7 @@
           </a:p>
           <a:p>
             <a:pPr algn="l">
-              <a:defRPr sz="1000">
+              <a:defRPr sz="919">
                 <a:solidFill>
                   <a:srgbClr val="38BDF8"/>
                 </a:solidFill>
@@ -11432,7 +11601,7 @@
           </a:p>
           <a:p>
             <a:pPr algn="l">
-              <a:defRPr sz="1000">
+              <a:defRPr sz="919">
                 <a:solidFill>
                   <a:srgbClr val="38BDF8"/>
                 </a:solidFill>
@@ -11445,20 +11614,20 @@
           </a:p>
           <a:p>
             <a:pPr algn="l">
-              <a:defRPr sz="1000">
-                <a:solidFill>
-                  <a:srgbClr val="38BDF8"/>
-                </a:solidFill>
-                <a:latin typeface="Consolas"/>
-              </a:defRPr>
-            </a:pPr>
-            <a:r>
-              <a:t>        _reservation = fresh;</a:t>
-            </a:r>
-          </a:p>
-          <a:p>
-            <a:pPr algn="l">
-              <a:defRPr sz="1000">
+              <a:defRPr sz="919">
+                <a:solidFill>
+                  <a:srgbClr val="38BDF8"/>
+                </a:solidFill>
+                <a:latin typeface="Consolas"/>
+              </a:defRPr>
+            </a:pPr>
+            <a:r>
+              <a:t>        _reservation = fresh; // تحديث التذكرة في واجهة المريض</a:t>
+            </a:r>
+          </a:p>
+          <a:p>
+            <a:pPr algn="l">
+              <a:defRPr sz="919">
                 <a:solidFill>
                   <a:srgbClr val="38BDF8"/>
                 </a:solidFill>
@@ -11471,7 +11640,7 @@
           </a:p>
           <a:p>
             <a:pPr algn="l">
-              <a:defRPr sz="1000">
+              <a:defRPr sz="919">
                 <a:solidFill>
                   <a:srgbClr val="38BDF8"/>
                 </a:solidFill>
@@ -11484,7 +11653,7 @@
           </a:p>
           <a:p>
             <a:pPr algn="l">
-              <a:defRPr sz="1000">
+              <a:defRPr sz="919">
                 <a:solidFill>
                   <a:srgbClr val="F472B6"/>
                 </a:solidFill>
@@ -11497,46 +11666,46 @@
           </a:p>
           <a:p>
             <a:pPr algn="l">
-              <a:defRPr sz="1000">
-                <a:solidFill>
-                  <a:srgbClr val="38BDF8"/>
-                </a:solidFill>
-                <a:latin typeface="Consolas"/>
-              </a:defRPr>
-            </a:pPr>
-            <a:r>
-              <a:t>        t.cancel(); // إيقاف المؤقت</a:t>
-            </a:r>
-          </a:p>
-          <a:p>
-            <a:pPr algn="l">
-              <a:defRPr sz="1000">
-                <a:solidFill>
-                  <a:srgbClr val="38BDF8"/>
-                </a:solidFill>
-                <a:latin typeface="Consolas"/>
-              </a:defRPr>
-            </a:pPr>
-            <a:r>
-              <a:t>        HapticFeedback.heavyImpact();</a:t>
-            </a:r>
-          </a:p>
-          <a:p>
-            <a:pPr algn="l">
-              <a:defRPr sz="1000">
-                <a:solidFill>
-                  <a:srgbClr val="38BDF8"/>
-                </a:solidFill>
-                <a:latin typeface="Consolas"/>
-              </a:defRPr>
-            </a:pPr>
-            <a:r>
-              <a:t>        _showSuccessBadge(); // شارة الاستلام الخضراء</a:t>
-            </a:r>
-          </a:p>
-          <a:p>
-            <a:pPr algn="l">
-              <a:defRPr sz="1000">
+              <a:defRPr sz="919">
+                <a:solidFill>
+                  <a:srgbClr val="38BDF8"/>
+                </a:solidFill>
+                <a:latin typeface="Consolas"/>
+              </a:defRPr>
+            </a:pPr>
+            <a:r>
+              <a:t>        t.cancel(); // إيقاف الاستطلاع لتوفير الموارد</a:t>
+            </a:r>
+          </a:p>
+          <a:p>
+            <a:pPr algn="l">
+              <a:defRPr sz="919">
+                <a:solidFill>
+                  <a:srgbClr val="38BDF8"/>
+                </a:solidFill>
+                <a:latin typeface="Consolas"/>
+              </a:defRPr>
+            </a:pPr>
+            <a:r>
+              <a:t>        HapticFeedback.heavyImpact(); // اهتزاز تفاعلي</a:t>
+            </a:r>
+          </a:p>
+          <a:p>
+            <a:pPr algn="l">
+              <a:defRPr sz="919">
+                <a:solidFill>
+                  <a:srgbClr val="38BDF8"/>
+                </a:solidFill>
+                <a:latin typeface="Consolas"/>
+              </a:defRPr>
+            </a:pPr>
+            <a:r>
+              <a:t>        _showSuccessBadge(); // إظهار شارة الاستلام الخضراء</a:t>
+            </a:r>
+          </a:p>
+          <a:p>
+            <a:pPr algn="l">
+              <a:defRPr sz="919">
                 <a:solidFill>
                   <a:srgbClr val="38BDF8"/>
                 </a:solidFill>
@@ -11549,7 +11718,7 @@
           </a:p>
           <a:p>
             <a:pPr algn="l">
-              <a:defRPr sz="1000">
+              <a:defRPr sz="919">
                 <a:solidFill>
                   <a:srgbClr val="38BDF8"/>
                 </a:solidFill>
@@ -11562,7 +11731,7 @@
           </a:p>
           <a:p>
             <a:pPr algn="l">
-              <a:defRPr sz="1000">
+              <a:defRPr sz="919">
                 <a:solidFill>
                   <a:srgbClr val="38BDF8"/>
                 </a:solidFill>
@@ -11575,7 +11744,7 @@
           </a:p>
           <a:p>
             <a:pPr algn="l">
-              <a:defRPr sz="1000">
+              <a:defRPr sz="919">
                 <a:solidFill>
                   <a:srgbClr val="38BDF8"/>
                 </a:solidFill>
@@ -11677,8 +11846,8 @@
         </p:nvSpPr>
         <p:spPr>
           <a:xfrm>
-            <a:off x="6400800" y="1801368"/>
-            <a:ext cx="4846320" cy="4251959"/>
+            <a:off x="6400800" y="1783080"/>
+            <a:ext cx="4846320" cy="4279392"/>
           </a:xfrm>
           <a:prstGeom prst="rect">
             <a:avLst/>
@@ -11692,7 +11861,7 @@
           <a:lstStyle/>
           <a:p>
             <a:pPr algn="l">
-              <a:defRPr sz="1000">
+              <a:defRPr sz="919">
                 <a:solidFill>
                   <a:srgbClr val="94A3B8"/>
                 </a:solidFill>
@@ -11705,7 +11874,20 @@
           </a:p>
           <a:p>
             <a:pPr algn="l">
-              <a:defRPr sz="1000">
+              <a:defRPr sz="919">
+                <a:solidFill>
+                  <a:srgbClr val="94A3B8"/>
+                </a:solidFill>
+                <a:latin typeface="Consolas"/>
+              </a:defRPr>
+            </a:pPr>
+            <a:r>
+              <a:t>// فحص دوري كل 5 ثوانٍ لتحديث جدول الحجوزات دون إعادة تحميل الصفحة</a:t>
+            </a:r>
+          </a:p>
+          <a:p>
+            <a:pPr algn="l">
+              <a:defRPr sz="919">
                 <a:solidFill>
                   <a:srgbClr val="F472B6"/>
                 </a:solidFill>
@@ -11718,7 +11900,7 @@
           </a:p>
           <a:p>
             <a:pPr algn="l">
-              <a:defRPr sz="1000">
+              <a:defRPr sz="919">
                 <a:solidFill>
                   <a:srgbClr val="F472B6"/>
                 </a:solidFill>
@@ -11731,7 +11913,20 @@
           </a:p>
           <a:p>
             <a:pPr algn="l">
-              <a:defRPr sz="1000">
+              <a:defRPr sz="919">
+                <a:solidFill>
+                  <a:srgbClr val="94A3B8"/>
+                </a:solidFill>
+                <a:latin typeface="Consolas"/>
+              </a:defRPr>
+            </a:pPr>
+            <a:r>
+              <a:t>        // 1. جلب شريحة الـ HTML المحدثة للحجوزات الواردة من السيرفر</a:t>
+            </a:r>
+          </a:p>
+          <a:p>
+            <a:pPr algn="l">
+              <a:defRPr sz="919">
                 <a:solidFill>
                   <a:srgbClr val="F472B6"/>
                 </a:solidFill>
@@ -11744,7 +11939,7 @@
           </a:p>
           <a:p>
             <a:pPr algn="l">
-              <a:defRPr sz="1000">
+              <a:defRPr sz="919">
                 <a:solidFill>
                   <a:srgbClr val="F472B6"/>
                 </a:solidFill>
@@ -11757,7 +11952,7 @@
           </a:p>
           <a:p>
             <a:pPr algn="l">
-              <a:defRPr sz="1000">
+              <a:defRPr sz="919">
                 <a:solidFill>
                   <a:srgbClr val="F472B6"/>
                 </a:solidFill>
@@ -11770,7 +11965,7 @@
           </a:p>
           <a:p>
             <a:pPr algn="l">
-              <a:defRPr sz="1000">
+              <a:defRPr sz="919">
                 <a:solidFill>
                   <a:srgbClr val="38BDF8"/>
                 </a:solidFill>
@@ -11783,7 +11978,7 @@
           </a:p>
           <a:p>
             <a:pPr algn="l">
-              <a:defRPr sz="1000">
+              <a:defRPr sz="919">
                 <a:solidFill>
                   <a:srgbClr val="38BDF8"/>
                 </a:solidFill>
@@ -11796,7 +11991,7 @@
           </a:p>
           <a:p>
             <a:pPr algn="l">
-              <a:defRPr sz="1000">
+              <a:defRPr sz="919">
                 <a:solidFill>
                   <a:srgbClr val="38BDF8"/>
                 </a:solidFill>
@@ -11809,7 +12004,7 @@
           </a:p>
           <a:p>
             <a:pPr algn="l">
-              <a:defRPr sz="1000">
+              <a:defRPr sz="919">
                 <a:solidFill>
                   <a:srgbClr val="38BDF8"/>
                 </a:solidFill>
@@ -11822,7 +12017,20 @@
           </a:p>
           <a:p>
             <a:pPr algn="l">
-              <a:defRPr sz="1000">
+              <a:defRPr sz="919">
+                <a:solidFill>
+                  <a:srgbClr val="94A3B8"/>
+                </a:solidFill>
+                <a:latin typeface="Consolas"/>
+              </a:defRPr>
+            </a:pPr>
+            <a:r>
+              <a:t>            // 2. تحديث DOM فقط في حال وجود حجز جديد أو تغيير حالة</a:t>
+            </a:r>
+          </a:p>
+          <a:p>
+            <a:pPr algn="l">
+              <a:defRPr sz="919">
                 <a:solidFill>
                   <a:srgbClr val="F472B6"/>
                 </a:solidFill>
@@ -11835,7 +12043,7 @@
           </a:p>
           <a:p>
             <a:pPr algn="l">
-              <a:defRPr sz="1000">
+              <a:defRPr sz="919">
                 <a:solidFill>
                   <a:srgbClr val="38BDF8"/>
                 </a:solidFill>
@@ -11848,7 +12056,7 @@
           </a:p>
           <a:p>
             <a:pPr algn="l">
-              <a:defRPr sz="1000">
+              <a:defRPr sz="919">
                 <a:solidFill>
                   <a:srgbClr val="38BDF8"/>
                 </a:solidFill>
@@ -11861,7 +12069,7 @@
           </a:p>
           <a:p>
             <a:pPr algn="l">
-              <a:defRPr sz="1000">
+              <a:defRPr sz="919">
                 <a:solidFill>
                   <a:srgbClr val="38BDF8"/>
                 </a:solidFill>
@@ -11874,7 +12082,7 @@
           </a:p>
           <a:p>
             <a:pPr algn="l">
-              <a:defRPr sz="1000">
+              <a:defRPr sz="919">
                 <a:solidFill>
                   <a:srgbClr val="F472B6"/>
                 </a:solidFill>
@@ -11887,20 +12095,20 @@
           </a:p>
           <a:p>
             <a:pPr algn="l">
-              <a:defRPr sz="1000">
-                <a:solidFill>
-                  <a:srgbClr val="38BDF8"/>
-                </a:solidFill>
-                <a:latin typeface="Consolas"/>
-              </a:defRPr>
-            </a:pPr>
-            <a:r>
-              <a:t>        console.warn('Auto-sync check failed:', err);</a:t>
-            </a:r>
-          </a:p>
-          <a:p>
-            <a:pPr algn="l">
-              <a:defRPr sz="1000">
+              <a:defRPr sz="919">
+                <a:solidFill>
+                  <a:srgbClr val="38BDF8"/>
+                </a:solidFill>
+                <a:latin typeface="Consolas"/>
+              </a:defRPr>
+            </a:pPr>
+            <a:r>
+              <a:t>        console.warn('Auto-sync check failed:', err); // معالجة صامتة</a:t>
+            </a:r>
+          </a:p>
+          <a:p>
+            <a:pPr algn="l">
+              <a:defRPr sz="919">
                 <a:solidFill>
                   <a:srgbClr val="38BDF8"/>
                 </a:solidFill>
@@ -11913,7 +12121,7 @@
           </a:p>
           <a:p>
             <a:pPr algn="l">
-              <a:defRPr sz="1000">
+              <a:defRPr sz="919">
                 <a:solidFill>
                   <a:srgbClr val="38BDF8"/>
                 </a:solidFill>
@@ -11926,15 +12134,15 @@
           </a:p>
           <a:p>
             <a:pPr algn="l">
-              <a:defRPr sz="1000">
-                <a:solidFill>
-                  <a:srgbClr val="38BDF8"/>
-                </a:solidFill>
-                <a:latin typeface="Consolas"/>
-              </a:defRPr>
-            </a:pPr>
-            <a:r>
-              <a:t>setInterval(fetchLatestReservations, 5000); // كل 5 ثوانٍ</a:t>
+              <a:defRPr sz="919">
+                <a:solidFill>
+                  <a:srgbClr val="38BDF8"/>
+                </a:solidFill>
+                <a:latin typeface="Consolas"/>
+              </a:defRPr>
+            </a:pPr>
+            <a:r>
+              <a:t>setInterval(fetchLatestReservations, 5000); // تكرار الفحص دورياً</a:t>
             </a:r>
           </a:p>
         </p:txBody>
@@ -12242,8 +12450,8 @@
         </p:nvSpPr>
         <p:spPr>
           <a:xfrm>
-            <a:off x="914400" y="1801368"/>
-            <a:ext cx="4846320" cy="4251959"/>
+            <a:off x="914400" y="1783080"/>
+            <a:ext cx="4846320" cy="4279392"/>
           </a:xfrm>
           <a:prstGeom prst="rect">
             <a:avLst/>
@@ -12257,7 +12465,7 @@
           <a:lstStyle/>
           <a:p>
             <a:pPr algn="l">
-              <a:defRPr sz="1000">
+              <a:defRPr sz="919">
                 <a:solidFill>
                   <a:srgbClr val="94A3B8"/>
                 </a:solidFill>
@@ -12270,7 +12478,7 @@
           </a:p>
           <a:p>
             <a:pPr algn="l">
-              <a:defRPr sz="1000">
+              <a:defRPr sz="919">
                 <a:solidFill>
                   <a:srgbClr val="94A3B8"/>
                 </a:solidFill>
@@ -12283,7 +12491,20 @@
           </a:p>
           <a:p>
             <a:pPr algn="l">
-              <a:defRPr sz="1000">
+              <a:defRPr sz="919">
+                <a:solidFill>
+                  <a:srgbClr val="94A3B8"/>
+                </a:solidFill>
+                <a:latin typeface="Consolas"/>
+              </a:defRPr>
+            </a:pPr>
+            <a:r>
+              <a:t>// حمولة مزامنة المخزون والأسعار الواردة من برنامج محاسبة الصيدلية</a:t>
+            </a:r>
+          </a:p>
+          <a:p>
+            <a:pPr algn="l">
+              <a:defRPr sz="919">
                 <a:solidFill>
                   <a:srgbClr val="38BDF8"/>
                 </a:solidFill>
@@ -12296,7 +12517,7 @@
           </a:p>
           <a:p>
             <a:pPr algn="l">
-              <a:defRPr sz="1000">
+              <a:defRPr sz="919">
                 <a:solidFill>
                   <a:srgbClr val="38BDF8"/>
                 </a:solidFill>
@@ -12309,7 +12530,7 @@
           </a:p>
           <a:p>
             <a:pPr algn="l">
-              <a:defRPr sz="1000">
+              <a:defRPr sz="919">
                 <a:solidFill>
                   <a:srgbClr val="38BDF8"/>
                 </a:solidFill>
@@ -12322,46 +12543,46 @@
           </a:p>
           <a:p>
             <a:pPr algn="l">
-              <a:defRPr sz="1000">
-                <a:solidFill>
-                  <a:srgbClr val="38BDF8"/>
-                </a:solidFill>
-                <a:latin typeface="Consolas"/>
-              </a:defRPr>
-            </a:pPr>
-            <a:r>
-              <a:t>      "barcode": "6291100123456",</a:t>
-            </a:r>
-          </a:p>
-          <a:p>
-            <a:pPr algn="l">
-              <a:defRPr sz="1000">
-                <a:solidFill>
-                  <a:srgbClr val="38BDF8"/>
-                </a:solidFill>
-                <a:latin typeface="Consolas"/>
-              </a:defRPr>
-            </a:pPr>
-            <a:r>
-              <a:t>      "quantity": 25,</a:t>
-            </a:r>
-          </a:p>
-          <a:p>
-            <a:pPr algn="l">
-              <a:defRPr sz="1000">
-                <a:solidFill>
-                  <a:srgbClr val="38BDF8"/>
-                </a:solidFill>
-                <a:latin typeface="Consolas"/>
-              </a:defRPr>
-            </a:pPr>
-            <a:r>
-              <a:t>      "price": 1200.00</a:t>
-            </a:r>
-          </a:p>
-          <a:p>
-            <a:pPr algn="l">
-              <a:defRPr sz="1000">
+              <a:defRPr sz="919">
+                <a:solidFill>
+                  <a:srgbClr val="38BDF8"/>
+                </a:solidFill>
+                <a:latin typeface="Consolas"/>
+              </a:defRPr>
+            </a:pPr>
+            <a:r>
+              <a:t>      "barcode": "6291100123456", // باركود الصنف الدوائي</a:t>
+            </a:r>
+          </a:p>
+          <a:p>
+            <a:pPr algn="l">
+              <a:defRPr sz="919">
+                <a:solidFill>
+                  <a:srgbClr val="38BDF8"/>
+                </a:solidFill>
+                <a:latin typeface="Consolas"/>
+              </a:defRPr>
+            </a:pPr>
+            <a:r>
+              <a:t>      "quantity": 25,              // الكمية الجديدة بالمخزون</a:t>
+            </a:r>
+          </a:p>
+          <a:p>
+            <a:pPr algn="l">
+              <a:defRPr sz="919">
+                <a:solidFill>
+                  <a:srgbClr val="38BDF8"/>
+                </a:solidFill>
+                <a:latin typeface="Consolas"/>
+              </a:defRPr>
+            </a:pPr>
+            <a:r>
+              <a:t>      "price": 1200.00             // السعر الفعلي بالريال</a:t>
+            </a:r>
+          </a:p>
+          <a:p>
+            <a:pPr algn="l">
+              <a:defRPr sz="919">
                 <a:solidFill>
                   <a:srgbClr val="38BDF8"/>
                 </a:solidFill>
@@ -12374,7 +12595,7 @@
           </a:p>
           <a:p>
             <a:pPr algn="l">
-              <a:defRPr sz="1000">
+              <a:defRPr sz="919">
                 <a:solidFill>
                   <a:srgbClr val="38BDF8"/>
                 </a:solidFill>
@@ -12387,7 +12608,7 @@
           </a:p>
           <a:p>
             <a:pPr algn="l">
-              <a:defRPr sz="1000">
+              <a:defRPr sz="919">
                 <a:solidFill>
                   <a:srgbClr val="38BDF8"/>
                 </a:solidFill>
@@ -12400,7 +12621,7 @@
           </a:p>
           <a:p>
             <a:pPr algn="l">
-              <a:defRPr sz="1000">
+              <a:defRPr sz="919">
                 <a:solidFill>
                   <a:srgbClr val="38BDF8"/>
                 </a:solidFill>
@@ -12413,7 +12634,7 @@
           </a:p>
           <a:p>
             <a:pPr algn="l">
-              <a:defRPr sz="1000">
+              <a:defRPr sz="919">
                 <a:solidFill>
                   <a:srgbClr val="38BDF8"/>
                 </a:solidFill>
@@ -12426,7 +12647,7 @@
           </a:p>
           <a:p>
             <a:pPr algn="l">
-              <a:defRPr sz="1000">
+              <a:defRPr sz="919">
                 <a:solidFill>
                   <a:srgbClr val="38BDF8"/>
                 </a:solidFill>
@@ -12439,7 +12660,7 @@
           </a:p>
           <a:p>
             <a:pPr algn="l">
-              <a:defRPr sz="1000">
+              <a:defRPr sz="919">
                 <a:solidFill>
                   <a:srgbClr val="38BDF8"/>
                 </a:solidFill>
@@ -12452,7 +12673,7 @@
           </a:p>
           <a:p>
             <a:pPr algn="l">
-              <a:defRPr sz="1000">
+              <a:defRPr sz="919">
                 <a:solidFill>
                   <a:srgbClr val="38BDF8"/>
                 </a:solidFill>
@@ -12465,17 +12686,17 @@
           </a:p>
           <a:p>
             <a:pPr algn="l">
-              <a:defRPr sz="1000">
-                <a:solidFill>
-                  <a:srgbClr val="38BDF8"/>
-                </a:solidFill>
-                <a:latin typeface="Consolas"/>
-              </a:defRPr>
-            </a:pPr>
-          </a:p>
-          <a:p>
-            <a:pPr algn="l">
-              <a:defRPr sz="1000">
+              <a:defRPr sz="919">
+                <a:solidFill>
+                  <a:srgbClr val="38BDF8"/>
+                </a:solidFill>
+                <a:latin typeface="Consolas"/>
+              </a:defRPr>
+            </a:pPr>
+          </a:p>
+          <a:p>
+            <a:pPr algn="l">
+              <a:defRPr sz="919">
                 <a:solidFill>
                   <a:srgbClr val="94A3B8"/>
                 </a:solidFill>
@@ -12483,12 +12704,12 @@
               </a:defRPr>
             </a:pPr>
             <a:r>
-              <a:t>// الاستجابة الفورية:</a:t>
-            </a:r>
-          </a:p>
-          <a:p>
-            <a:pPr algn="l">
-              <a:defRPr sz="1000">
+              <a:t>// استجابة الخادم الفورية بنجاح المزامنة وتحديث الرصيد السحابي:</a:t>
+            </a:r>
+          </a:p>
+          <a:p>
+            <a:pPr algn="l">
+              <a:defRPr sz="919">
                 <a:solidFill>
                   <a:srgbClr val="38BDF8"/>
                 </a:solidFill>
@@ -12501,7 +12722,7 @@
           </a:p>
           <a:p>
             <a:pPr algn="l">
-              <a:defRPr sz="1000">
+              <a:defRPr sz="919">
                 <a:solidFill>
                   <a:srgbClr val="38BDF8"/>
                 </a:solidFill>
@@ -12514,7 +12735,7 @@
           </a:p>
           <a:p>
             <a:pPr algn="l">
-              <a:defRPr sz="1000">
+              <a:defRPr sz="919">
                 <a:solidFill>
                   <a:srgbClr val="38BDF8"/>
                 </a:solidFill>
@@ -12527,7 +12748,7 @@
           </a:p>
           <a:p>
             <a:pPr algn="l">
-              <a:defRPr sz="1000">
+              <a:defRPr sz="919">
                 <a:solidFill>
                   <a:srgbClr val="38BDF8"/>
                 </a:solidFill>
@@ -12540,7 +12761,7 @@
           </a:p>
           <a:p>
             <a:pPr algn="l">
-              <a:defRPr sz="1000">
+              <a:defRPr sz="919">
                 <a:solidFill>
                   <a:srgbClr val="38BDF8"/>
                 </a:solidFill>
@@ -12642,8 +12863,8 @@
         </p:nvSpPr>
         <p:spPr>
           <a:xfrm>
-            <a:off x="6400800" y="1801368"/>
-            <a:ext cx="4846320" cy="4251959"/>
+            <a:off x="6400800" y="1783080"/>
+            <a:ext cx="4846320" cy="4279392"/>
           </a:xfrm>
           <a:prstGeom prst="rect">
             <a:avLst/>
@@ -12657,7 +12878,7 @@
           <a:lstStyle/>
           <a:p>
             <a:pPr algn="l">
-              <a:defRPr sz="1000">
+              <a:defRPr sz="919">
                 <a:solidFill>
                   <a:srgbClr val="94A3B8"/>
                 </a:solidFill>
@@ -12670,7 +12891,20 @@
           </a:p>
           <a:p>
             <a:pPr algn="l">
-              <a:defRPr sz="1000">
+              <a:defRPr sz="919">
+                <a:solidFill>
+                  <a:srgbClr val="94A3B8"/>
+                </a:solidFill>
+                <a:latin typeface="Consolas"/>
+              </a:defRPr>
+            </a:pPr>
+            <a:r>
+              <a:t>// دالة معالجة المزامنة الدورية للمخزون من أنظمة الـ ERP ونقاط البيع</a:t>
+            </a:r>
+          </a:p>
+          <a:p>
+            <a:pPr algn="l">
+              <a:defRPr sz="919">
                 <a:solidFill>
                   <a:srgbClr val="F472B6"/>
                 </a:solidFill>
@@ -12683,20 +12917,20 @@
           </a:p>
           <a:p>
             <a:pPr algn="l">
-              <a:defRPr sz="1000">
-                <a:solidFill>
-                  <a:srgbClr val="38BDF8"/>
-                </a:solidFill>
-                <a:latin typeface="Consolas"/>
-              </a:defRPr>
-            </a:pPr>
-            <a:r>
-              <a:t>    $pharmacy = $this-&gt;resolvePharmacy($request);</a:t>
-            </a:r>
-          </a:p>
-          <a:p>
-            <a:pPr algn="l">
-              <a:defRPr sz="1000">
+              <a:defRPr sz="919">
+                <a:solidFill>
+                  <a:srgbClr val="38BDF8"/>
+                </a:solidFill>
+                <a:latin typeface="Consolas"/>
+              </a:defRPr>
+            </a:pPr>
+            <a:r>
+              <a:t>    $pharmacy = $this-&gt;resolvePharmacy($request); // استخراج هوية الصيدلية</a:t>
+            </a:r>
+          </a:p>
+          <a:p>
+            <a:pPr algn="l">
+              <a:defRPr sz="919">
                 <a:solidFill>
                   <a:srgbClr val="38BDF8"/>
                 </a:solidFill>
@@ -12709,7 +12943,7 @@
           </a:p>
           <a:p>
             <a:pPr algn="l">
-              <a:defRPr sz="1000">
+              <a:defRPr sz="919">
                 <a:solidFill>
                   <a:srgbClr val="38BDF8"/>
                 </a:solidFill>
@@ -12722,7 +12956,7 @@
           </a:p>
           <a:p>
             <a:pPr algn="l">
-              <a:defRPr sz="1000">
+              <a:defRPr sz="919">
                 <a:solidFill>
                   <a:srgbClr val="38BDF8"/>
                 </a:solidFill>
@@ -12735,7 +12969,7 @@
           </a:p>
           <a:p>
             <a:pPr algn="l">
-              <a:defRPr sz="1000">
+              <a:defRPr sz="919">
                 <a:solidFill>
                   <a:srgbClr val="38BDF8"/>
                 </a:solidFill>
@@ -12748,7 +12982,7 @@
           </a:p>
           <a:p>
             <a:pPr algn="l">
-              <a:defRPr sz="1000">
+              <a:defRPr sz="919">
                 <a:solidFill>
                   <a:srgbClr val="38BDF8"/>
                 </a:solidFill>
@@ -12761,7 +12995,7 @@
           </a:p>
           <a:p>
             <a:pPr algn="l">
-              <a:defRPr sz="1000">
+              <a:defRPr sz="919">
                 <a:solidFill>
                   <a:srgbClr val="38BDF8"/>
                 </a:solidFill>
@@ -12774,17 +13008,30 @@
           </a:p>
           <a:p>
             <a:pPr algn="l">
-              <a:defRPr sz="1000">
-                <a:solidFill>
-                  <a:srgbClr val="38BDF8"/>
-                </a:solidFill>
-                <a:latin typeface="Consolas"/>
-              </a:defRPr>
-            </a:pPr>
-          </a:p>
-          <a:p>
-            <a:pPr algn="l">
-              <a:defRPr sz="1000">
+              <a:defRPr sz="919">
+                <a:solidFill>
+                  <a:srgbClr val="38BDF8"/>
+                </a:solidFill>
+                <a:latin typeface="Consolas"/>
+              </a:defRPr>
+            </a:pPr>
+          </a:p>
+          <a:p>
+            <a:pPr algn="l">
+              <a:defRPr sz="919">
+                <a:solidFill>
+                  <a:srgbClr val="94A3B8"/>
+                </a:solidFill>
+                <a:latin typeface="Consolas"/>
+              </a:defRPr>
+            </a:pPr>
+            <a:r>
+              <a:t>    // معالجة كل صنف وتحديث كميته وسعره بالسجلات السحابية</a:t>
+            </a:r>
+          </a:p>
+          <a:p>
+            <a:pPr algn="l">
+              <a:defRPr sz="919">
                 <a:solidFill>
                   <a:srgbClr val="38BDF8"/>
                 </a:solidFill>
@@ -12797,7 +13044,7 @@
           </a:p>
           <a:p>
             <a:pPr algn="l">
-              <a:defRPr sz="1000">
+              <a:defRPr sz="919">
                 <a:solidFill>
                   <a:srgbClr val="38BDF8"/>
                 </a:solidFill>
@@ -12810,7 +13057,7 @@
           </a:p>
           <a:p>
             <a:pPr algn="l">
-              <a:defRPr sz="1000">
+              <a:defRPr sz="919">
                 <a:solidFill>
                   <a:srgbClr val="F472B6"/>
                 </a:solidFill>
@@ -12823,7 +13070,7 @@
           </a:p>
           <a:p>
             <a:pPr algn="l">
-              <a:defRPr sz="1000">
+              <a:defRPr sz="919">
                 <a:solidFill>
                   <a:srgbClr val="38BDF8"/>
                 </a:solidFill>
@@ -12836,7 +13083,7 @@
           </a:p>
           <a:p>
             <a:pPr algn="l">
-              <a:defRPr sz="1000">
+              <a:defRPr sz="919">
                 <a:solidFill>
                   <a:srgbClr val="38BDF8"/>
                 </a:solidFill>
@@ -12849,7 +13096,7 @@
           </a:p>
           <a:p>
             <a:pPr algn="l">
-              <a:defRPr sz="1000">
+              <a:defRPr sz="919">
                 <a:solidFill>
                   <a:srgbClr val="38BDF8"/>
                 </a:solidFill>
@@ -12862,7 +13109,7 @@
           </a:p>
           <a:p>
             <a:pPr algn="l">
-              <a:defRPr sz="1000">
+              <a:defRPr sz="919">
                 <a:solidFill>
                   <a:srgbClr val="38BDF8"/>
                 </a:solidFill>
@@ -12875,7 +13122,7 @@
           </a:p>
           <a:p>
             <a:pPr algn="l">
-              <a:defRPr sz="1000">
+              <a:defRPr sz="919">
                 <a:solidFill>
                   <a:srgbClr val="38BDF8"/>
                 </a:solidFill>
@@ -12888,7 +13135,7 @@
           </a:p>
           <a:p>
             <a:pPr algn="l">
-              <a:defRPr sz="1000">
+              <a:defRPr sz="919">
                 <a:solidFill>
                   <a:srgbClr val="38BDF8"/>
                 </a:solidFill>
@@ -12901,7 +13148,7 @@
           </a:p>
           <a:p>
             <a:pPr algn="l">
-              <a:defRPr sz="1000">
+              <a:defRPr sz="919">
                 <a:solidFill>
                   <a:srgbClr val="F472B6"/>
                 </a:solidFill>
@@ -12914,7 +13161,7 @@
           </a:p>
           <a:p>
             <a:pPr algn="l">
-              <a:defRPr sz="1000">
+              <a:defRPr sz="919">
                 <a:solidFill>
                   <a:srgbClr val="38BDF8"/>
                 </a:solidFill>

</xml_diff>